<commit_message>
fix: switch week 8 presentation to Rubik per design system
</commit_message>
<xml_diff>
--- a/READMEs/sem_7/week8/attachments/PiConstruct_Правовая_база.pptx
+++ b/READMEs/sem_7/week8/attachments/PiConstruct_Правовая_база.pptx
@@ -3137,7 +3137,7 @@
                 <a:solidFill>
                   <a:srgbClr val="7A899F"/>
                 </a:solidFill>
-                <a:latin typeface="Segoe UI"/>
+                <a:latin typeface="Rubik"/>
               </a:rPr>
               <a:t>ПРАКТИЧЕСКОЕ ЗАНЯТИЕ №16 · ЮРИДИЧЕСКИЕ АСПЕКТЫ СТАРТАПА</a:t>
             </a:r>
@@ -3172,11 +3172,11 @@
               </a:lnSpc>
             </a:pPr>
             <a:r>
-              <a:rPr sz="4800" b="0">
+              <a:rPr sz="4800" b="1">
                 <a:solidFill>
                   <a:srgbClr val="FFFFFF"/>
                 </a:solidFill>
-                <a:latin typeface="Segoe UI Semibold"/>
+                <a:latin typeface="Rubik"/>
               </a:rPr>
               <a:t>Правовая база PiConstruct</a:t>
             </a:r>
@@ -3215,7 +3215,7 @@
                 <a:solidFill>
                   <a:srgbClr val="C9CFD8"/>
                 </a:solidFill>
-                <a:latin typeface="Segoe UI"/>
+                <a:latin typeface="Rubik"/>
               </a:rPr>
               <a:t>Форма бизнеса, интеллектуальная собственность и договор между сооснователями —</a:t>
             </a:r>
@@ -3231,7 +3231,7 @@
                 <a:solidFill>
                   <a:srgbClr val="C9CFD8"/>
                 </a:solidFill>
-                <a:latin typeface="Segoe UI"/>
+                <a:latin typeface="Rubik"/>
               </a:rPr>
               <a:t>правовые решения для команды из пяти человек на пороге первых продаж</a:t>
             </a:r>
@@ -3314,11 +3314,11 @@
               </a:lnSpc>
             </a:pPr>
             <a:r>
-              <a:rPr sz="2600" b="0">
+              <a:rPr sz="2600" b="1">
                 <a:solidFill>
                   <a:srgbClr val="2BDD93"/>
                 </a:solidFill>
-                <a:latin typeface="Segoe UI Semibold"/>
+                <a:latin typeface="Rubik"/>
               </a:rPr>
               <a:t>5</a:t>
             </a:r>
@@ -3357,7 +3357,7 @@
                 <a:solidFill>
                   <a:srgbClr val="C9CFD8"/>
                 </a:solidFill>
-                <a:latin typeface="Segoe UI"/>
+                <a:latin typeface="Rubik"/>
               </a:rPr>
               <a:t>участников — доли и права пока не зафиксированы юридически</a:t>
             </a:r>
@@ -3440,13 +3440,13 @@
               </a:lnSpc>
             </a:pPr>
             <a:r>
-              <a:rPr sz="2200" b="0">
+              <a:rPr sz="2200" b="1">
                 <a:solidFill>
                   <a:srgbClr val="2BDD93"/>
                 </a:solidFill>
-                <a:latin typeface="Segoe UI Semibold"/>
-              </a:rPr>
-              <a:t>ИП → ООО</a:t>
+                <a:latin typeface="Rubik"/>
+              </a:rPr>
+              <a:t>ИП, затем ООО</a:t>
             </a:r>
           </a:p>
         </p:txBody>
@@ -3483,7 +3483,7 @@
                 <a:solidFill>
                   <a:srgbClr val="C9CFD8"/>
                 </a:solidFill>
-                <a:latin typeface="Segoe UI"/>
+                <a:latin typeface="Rubik"/>
               </a:rPr>
               <a:t>двухэтапная модель: старт на ИП, ООО — по триггеру</a:t>
             </a:r>
@@ -3566,11 +3566,11 @@
               </a:lnSpc>
             </a:pPr>
             <a:r>
-              <a:rPr sz="2600" b="0">
+              <a:rPr sz="2600" b="1">
                 <a:solidFill>
                   <a:srgbClr val="2BDD93"/>
                 </a:solidFill>
-                <a:latin typeface="Segoe UI Semibold"/>
+                <a:latin typeface="Rubik"/>
               </a:rPr>
               <a:t>42 000 ₽</a:t>
             </a:r>
@@ -3609,7 +3609,7 @@
                 <a:solidFill>
                   <a:srgbClr val="C9CFD8"/>
                 </a:solidFill>
-                <a:latin typeface="Segoe UI"/>
+                <a:latin typeface="Rubik"/>
               </a:rPr>
               <a:t>пошлины за товарный знак в 3 классах МКТУ</a:t>
             </a:r>
@@ -3692,11 +3692,11 @@
               </a:lnSpc>
             </a:pPr>
             <a:r>
-              <a:rPr sz="2600" b="0">
+              <a:rPr sz="2600" b="1">
                 <a:solidFill>
                   <a:srgbClr val="2BDD93"/>
                 </a:solidFill>
-                <a:latin typeface="Segoe UI Semibold"/>
+                <a:latin typeface="Rubik"/>
               </a:rPr>
               <a:t>11</a:t>
             </a:r>
@@ -3735,7 +3735,7 @@
                 <a:solidFill>
                   <a:srgbClr val="C9CFD8"/>
                 </a:solidFill>
-                <a:latin typeface="Segoe UI"/>
+                <a:latin typeface="Rubik"/>
               </a:rPr>
               <a:t>разделов прототипа партнёрского соглашения</a:t>
             </a:r>
@@ -3774,7 +3774,7 @@
                 <a:solidFill>
                   <a:srgbClr val="7A899F"/>
                 </a:solidFill>
-                <a:latin typeface="Segoe UI"/>
+                <a:latin typeface="Rubik"/>
               </a:rPr>
               <a:t>Команда №1: Савельев С. · Овчаренко К. · Валянский А. · Миняев Т. · Паркаев И.</a:t>
             </a:r>
@@ -3809,11 +3809,11 @@
               </a:lnSpc>
             </a:pPr>
             <a:r>
-              <a:rPr sz="1000" b="0">
+              <a:rPr sz="1000" b="1">
                 <a:solidFill>
                   <a:srgbClr val="2BDD93"/>
                 </a:solidFill>
-                <a:latin typeface="Segoe UI Semibold"/>
+                <a:latin typeface="Rubik"/>
               </a:rPr>
               <a:t>PiConstruct  ·  ПЗ №16 · правовая база стартапа</a:t>
             </a:r>
@@ -3852,7 +3852,7 @@
                 <a:solidFill>
                   <a:srgbClr val="7A899F"/>
                 </a:solidFill>
-                <a:latin typeface="Segoe UI"/>
+                <a:latin typeface="Rubik"/>
               </a:rPr>
               <a:t>1 / 10</a:t>
             </a:r>
@@ -3917,7 +3917,7 @@
                 <a:solidFill>
                   <a:srgbClr val="7A899F"/>
                 </a:solidFill>
-                <a:latin typeface="Segoe UI"/>
+                <a:latin typeface="Rubik"/>
               </a:rPr>
               <a:t>ВЫВОД</a:t>
             </a:r>
@@ -3952,11 +3952,11 @@
               </a:lnSpc>
             </a:pPr>
             <a:r>
-              <a:rPr sz="3000" b="0">
+              <a:rPr sz="3000" b="1">
                 <a:solidFill>
                   <a:srgbClr val="FFFFFF"/>
                 </a:solidFill>
-                <a:latin typeface="Segoe UI Semibold"/>
+                <a:latin typeface="Rubik"/>
               </a:rPr>
               <a:t>Правовой каркас готов до первых продаж</a:t>
             </a:r>
@@ -3991,11 +3991,11 @@
               </a:lnSpc>
             </a:pPr>
             <a:r>
-              <a:rPr sz="1000" b="0">
+              <a:rPr sz="1000" b="1">
                 <a:solidFill>
                   <a:srgbClr val="2BDD93"/>
                 </a:solidFill>
-                <a:latin typeface="Segoe UI Semibold"/>
+                <a:latin typeface="Rubik"/>
               </a:rPr>
               <a:t>PiConstruct  ·  ПЗ №16 · правовая база стартапа</a:t>
             </a:r>
@@ -4034,7 +4034,7 @@
                 <a:solidFill>
                   <a:srgbClr val="7A899F"/>
                 </a:solidFill>
-                <a:latin typeface="Segoe UI"/>
+                <a:latin typeface="Rubik"/>
               </a:rPr>
               <a:t>10 / 10</a:t>
             </a:r>
@@ -4121,7 +4121,7 @@
                 <a:solidFill>
                   <a:srgbClr val="2BDD93"/>
                 </a:solidFill>
-                <a:latin typeface="Segoe UI"/>
+                <a:latin typeface="Rubik"/>
               </a:rPr>
               <a:t>МОДЕЛЬ</a:t>
             </a:r>
@@ -4163,18 +4163,18 @@
                 <a:solidFill>
                   <a:srgbClr val="2BDD93"/>
                 </a:solidFill>
-                <a:latin typeface="Segoe UI"/>
-              </a:rPr>
-              <a:t>▪  </a:t>
+                <a:latin typeface="Rubik"/>
+              </a:rPr>
+              <a:t>•  </a:t>
             </a:r>
             <a:r>
               <a:rPr sz="1100">
                 <a:solidFill>
                   <a:srgbClr val="2BDD93"/>
                 </a:solidFill>
-                <a:latin typeface="Segoe UI"/>
-              </a:rPr>
-              <a:t>ИП на УСН 6% — уже в модели недели 7</a:t>
+                <a:latin typeface="Rubik"/>
+              </a:rPr>
+              <a:t>ИП на УСН 6% — уже в модели недели 7</a:t>
             </a:r>
           </a:p>
           <a:p>
@@ -4191,16 +4191,16 @@
                 <a:solidFill>
                   <a:srgbClr val="2BDD93"/>
                 </a:solidFill>
-                <a:latin typeface="Segoe UI"/>
-              </a:rPr>
-              <a:t>▪  </a:t>
+                <a:latin typeface="Rubik"/>
+              </a:rPr>
+              <a:t>•  </a:t>
             </a:r>
             <a:r>
               <a:rPr sz="1100">
                 <a:solidFill>
                   <a:srgbClr val="2BDD93"/>
                 </a:solidFill>
-                <a:latin typeface="Segoe UI"/>
+                <a:latin typeface="Rubik"/>
               </a:rPr>
               <a:t>ООО по триггеру: 30 000 ₽/мес × 3, инвестор или наём</a:t>
             </a:r>
@@ -4219,16 +4219,16 @@
                 <a:solidFill>
                   <a:srgbClr val="2BDD93"/>
                 </a:solidFill>
-                <a:latin typeface="Segoe UI"/>
-              </a:rPr>
-              <a:t>▪  </a:t>
+                <a:latin typeface="Rubik"/>
+              </a:rPr>
+              <a:t>•  </a:t>
             </a:r>
             <a:r>
               <a:rPr sz="1100">
                 <a:solidFill>
                   <a:srgbClr val="2BDD93"/>
                 </a:solidFill>
-                <a:latin typeface="Segoe UI"/>
+                <a:latin typeface="Rubik"/>
               </a:rPr>
               <a:t>доли 20% × 5, УК 50 000 ₽, решения 3/5</a:t>
             </a:r>
@@ -4247,16 +4247,16 @@
                 <a:solidFill>
                   <a:srgbClr val="2BDD93"/>
                 </a:solidFill>
-                <a:latin typeface="Segoe UI"/>
-              </a:rPr>
-              <a:t>▪  </a:t>
+                <a:latin typeface="Rubik"/>
+              </a:rPr>
+              <a:t>•  </a:t>
             </a:r>
             <a:r>
               <a:rPr sz="1100">
                 <a:solidFill>
                   <a:srgbClr val="2BDD93"/>
                 </a:solidFill>
-                <a:latin typeface="Segoe UI"/>
+                <a:latin typeface="Rubik"/>
               </a:rPr>
               <a:t>регистрация электронно — 0 ₽ пошлин</a:t>
             </a:r>
@@ -4343,7 +4343,7 @@
                 <a:solidFill>
                   <a:srgbClr val="2BDD93"/>
                 </a:solidFill>
-                <a:latin typeface="Segoe UI"/>
+                <a:latin typeface="Rubik"/>
               </a:rPr>
               <a:t>ИНТЕЛЛЕКТУАЛЬНАЯ СОБСТВЕННОСТЬ</a:t>
             </a:r>
@@ -4385,16 +4385,16 @@
                 <a:solidFill>
                   <a:srgbClr val="2BDD93"/>
                 </a:solidFill>
-                <a:latin typeface="Segoe UI"/>
-              </a:rPr>
-              <a:t>▪  </a:t>
+                <a:latin typeface="Rubik"/>
+              </a:rPr>
+              <a:t>•  </a:t>
             </a:r>
             <a:r>
               <a:rPr sz="1100">
                 <a:solidFill>
                   <a:srgbClr val="2BDD93"/>
                 </a:solidFill>
-                <a:latin typeface="Segoe UI"/>
+                <a:latin typeface="Rubik"/>
               </a:rPr>
               <a:t>7 документов: от отчуждения прав до оферты</a:t>
             </a:r>
@@ -4413,16 +4413,16 @@
                 <a:solidFill>
                   <a:srgbClr val="2BDD93"/>
                 </a:solidFill>
-                <a:latin typeface="Segoe UI"/>
-              </a:rPr>
-              <a:t>▪  </a:t>
+                <a:latin typeface="Rubik"/>
+              </a:rPr>
+              <a:t>•  </a:t>
             </a:r>
             <a:r>
               <a:rPr sz="1100">
                 <a:solidFill>
                   <a:srgbClr val="2BDD93"/>
                 </a:solidFill>
-                <a:latin typeface="Segoe UI"/>
+                <a:latin typeface="Rubik"/>
               </a:rPr>
               <a:t>знак «PiConstruct»: 8–⁠12 мес. и 42 000 ₽ пошлин в 3 классах МКТУ</a:t>
             </a:r>
@@ -4441,16 +4441,16 @@
                 <a:solidFill>
                   <a:srgbClr val="2BDD93"/>
                 </a:solidFill>
-                <a:latin typeface="Segoe UI"/>
-              </a:rPr>
-              <a:t>▪  </a:t>
+                <a:latin typeface="Rubik"/>
+              </a:rPr>
+              <a:t>•  </a:t>
             </a:r>
             <a:r>
               <a:rPr sz="1100">
                 <a:solidFill>
                   <a:srgbClr val="2BDD93"/>
                 </a:solidFill>
-                <a:latin typeface="Segoe UI"/>
+                <a:latin typeface="Rubik"/>
               </a:rPr>
               <a:t>piconstruct.ru свободен — регистрируем до заявки</a:t>
             </a:r>
@@ -4469,16 +4469,16 @@
                 <a:solidFill>
                   <a:srgbClr val="2BDD93"/>
                 </a:solidFill>
-                <a:latin typeface="Segoe UI"/>
-              </a:rPr>
-              <a:t>▪  </a:t>
+                <a:latin typeface="Rubik"/>
+              </a:rPr>
+              <a:t>•  </a:t>
             </a:r>
             <a:r>
               <a:rPr sz="1100">
                 <a:solidFill>
                   <a:srgbClr val="2BDD93"/>
                 </a:solidFill>
-                <a:latin typeface="Segoe UI"/>
+                <a:latin typeface="Rubik"/>
               </a:rPr>
               <a:t>GPL-исходники образа публикуем; ФЗ-152 — уведомление РКН</a:t>
             </a:r>
@@ -4565,7 +4565,7 @@
                 <a:solidFill>
                   <a:srgbClr val="2BDD93"/>
                 </a:solidFill>
-                <a:latin typeface="Segoe UI"/>
+                <a:latin typeface="Rubik"/>
               </a:rPr>
               <a:t>ДОГОВОР</a:t>
             </a:r>
@@ -4607,16 +4607,16 @@
                 <a:solidFill>
                   <a:srgbClr val="2BDD93"/>
                 </a:solidFill>
-                <a:latin typeface="Segoe UI"/>
-              </a:rPr>
-              <a:t>▪  </a:t>
+                <a:latin typeface="Rubik"/>
+              </a:rPr>
+              <a:t>•  </a:t>
             </a:r>
             <a:r>
               <a:rPr sz="1100">
                 <a:solidFill>
                   <a:srgbClr val="2BDD93"/>
                 </a:solidFill>
-                <a:latin typeface="Segoe UI"/>
+                <a:latin typeface="Rubik"/>
               </a:rPr>
               <a:t>партнёрское соглашение: 11 разделов, прототип готов</a:t>
             </a:r>
@@ -4635,16 +4635,16 @@
                 <a:solidFill>
                   <a:srgbClr val="2BDD93"/>
                 </a:solidFill>
-                <a:latin typeface="Segoe UI"/>
-              </a:rPr>
-              <a:t>▪  </a:t>
+                <a:latin typeface="Rubik"/>
+              </a:rPr>
+              <a:t>•  </a:t>
             </a:r>
             <a:r>
               <a:rPr sz="1100">
                 <a:solidFill>
                   <a:srgbClr val="2BDD93"/>
                 </a:solidFill>
-                <a:latin typeface="Segoe UI"/>
+                <a:latin typeface="Rubik"/>
               </a:rPr>
               <a:t>вестинг 4 года / клифф 12 мес. — равные доли справедливы</a:t>
             </a:r>
@@ -4663,16 +4663,16 @@
                 <a:solidFill>
                   <a:srgbClr val="2BDD93"/>
                 </a:solidFill>
-                <a:latin typeface="Segoe UI"/>
-              </a:rPr>
-              <a:t>▪  </a:t>
+                <a:latin typeface="Rubik"/>
+              </a:rPr>
+              <a:t>•  </a:t>
             </a:r>
             <a:r>
               <a:rPr sz="1100">
                 <a:solidFill>
                   <a:srgbClr val="2BDD93"/>
                 </a:solidFill>
-                <a:latin typeface="Segoe UI"/>
+                <a:latin typeface="Rubik"/>
               </a:rPr>
               <a:t>выход через ROFR, неконкуренция 12 месяцев</a:t>
             </a:r>
@@ -4691,16 +4691,16 @@
                 <a:solidFill>
                   <a:srgbClr val="2BDD93"/>
                 </a:solidFill>
-                <a:latin typeface="Segoe UI"/>
-              </a:rPr>
-              <a:t>▪  </a:t>
+                <a:latin typeface="Rubik"/>
+              </a:rPr>
+              <a:t>•  </a:t>
             </a:r>
             <a:r>
               <a:rPr sz="1100">
                 <a:solidFill>
                   <a:srgbClr val="2BDD93"/>
                 </a:solidFill>
-                <a:latin typeface="Segoe UI"/>
+                <a:latin typeface="Rubik"/>
               </a:rPr>
               <a:t>после ООО — устав и корпоративный договор</a:t>
             </a:r>
@@ -4787,7 +4787,7 @@
                 <a:solidFill>
                   <a:srgbClr val="2BDD93"/>
                 </a:solidFill>
-                <a:latin typeface="Segoe UI"/>
+                <a:latin typeface="Rubik"/>
               </a:rPr>
               <a:t>СВЯЗКА С ПЛАНОМ</a:t>
             </a:r>
@@ -4826,9 +4826,9 @@
                 <a:solidFill>
                   <a:srgbClr val="C9CFD8"/>
                 </a:solidFill>
-                <a:latin typeface="Segoe UI"/>
-              </a:rPr>
-              <a:t>Уже сделано: политика ПДн и cookie-согласие (неделя 2–⁠3), схема ИП в расчётах (неделя 7). Дальше: NDA с казахстанским партнёром — ноябрь 2026, фаза 0 недели 7.</a:t>
+                <a:latin typeface="Rubik"/>
+              </a:rPr>
+              <a:t>Уже сделано: политика ПДн и cookie-согласие (неделя 2–⁠3), схема ИП в расчётах (неделя 7). Дальше: NDA с казахстанским партнёром — ноябрь 2026, фаза 0 недели 7.</a:t>
             </a:r>
           </a:p>
         </p:txBody>
@@ -4891,7 +4891,7 @@
                 <a:solidFill>
                   <a:srgbClr val="7A899F"/>
                 </a:solidFill>
-                <a:latin typeface="Segoe UI"/>
+                <a:latin typeface="Rubik"/>
               </a:rPr>
               <a:t>ЗАДАНИЕ 1 · ПРАВОВАЯ СТРУКТУРА</a:t>
             </a:r>
@@ -4926,11 +4926,11 @@
               </a:lnSpc>
             </a:pPr>
             <a:r>
-              <a:rPr sz="3000" b="0">
+              <a:rPr sz="3000" b="1">
                 <a:solidFill>
                   <a:srgbClr val="FFFFFF"/>
                 </a:solidFill>
-                <a:latin typeface="Segoe UI Semibold"/>
+                <a:latin typeface="Rubik"/>
               </a:rPr>
               <a:t>Выбор формы: почему не сразу ООО</a:t>
             </a:r>
@@ -4965,11 +4965,11 @@
               </a:lnSpc>
             </a:pPr>
             <a:r>
-              <a:rPr sz="1000" b="0">
+              <a:rPr sz="1000" b="1">
                 <a:solidFill>
                   <a:srgbClr val="2BDD93"/>
                 </a:solidFill>
-                <a:latin typeface="Segoe UI Semibold"/>
+                <a:latin typeface="Rubik"/>
               </a:rPr>
               <a:t>PiConstruct  ·  ПЗ №16 · правовая база стартапа</a:t>
             </a:r>
@@ -5008,7 +5008,7 @@
                 <a:solidFill>
                   <a:srgbClr val="7A899F"/>
                 </a:solidFill>
-                <a:latin typeface="Segoe UI"/>
+                <a:latin typeface="Rubik"/>
               </a:rPr>
               <a:t>2 / 10</a:t>
             </a:r>
@@ -5091,11 +5091,11 @@
               </a:lnSpc>
             </a:pPr>
             <a:r>
-              <a:rPr sz="1150" b="0">
+              <a:rPr sz="1150" b="1">
                 <a:solidFill>
                   <a:srgbClr val="7A899F"/>
                 </a:solidFill>
-                <a:latin typeface="Segoe UI Semibold"/>
+                <a:latin typeface="Rubik"/>
               </a:rPr>
               <a:t>Критерий</a:t>
             </a:r>
@@ -5130,11 +5130,11 @@
               </a:lnSpc>
             </a:pPr>
             <a:r>
-              <a:rPr sz="1150" b="0">
+              <a:rPr sz="1150" b="1">
                 <a:solidFill>
                   <a:srgbClr val="7A899F"/>
                 </a:solidFill>
-                <a:latin typeface="Segoe UI Semibold"/>
+                <a:latin typeface="Rubik"/>
               </a:rPr>
               <a:t>ИП</a:t>
             </a:r>
@@ -5169,11 +5169,11 @@
               </a:lnSpc>
             </a:pPr>
             <a:r>
-              <a:rPr sz="1150" b="0">
+              <a:rPr sz="1150" b="1">
                 <a:solidFill>
                   <a:srgbClr val="7A899F"/>
                 </a:solidFill>
-                <a:latin typeface="Segoe UI Semibold"/>
+                <a:latin typeface="Rubik"/>
               </a:rPr>
               <a:t>ООО</a:t>
             </a:r>
@@ -5243,11 +5243,11 @@
               </a:lnSpc>
             </a:pPr>
             <a:r>
-              <a:rPr sz="1250" b="0">
+              <a:rPr sz="1250" b="1">
                 <a:solidFill>
                   <a:srgbClr val="FFFFFF"/>
                 </a:solidFill>
-                <a:latin typeface="Segoe UI Semibold"/>
+                <a:latin typeface="Rubik"/>
               </a:rPr>
               <a:t>Ответственность по долгам</a:t>
             </a:r>
@@ -5286,7 +5286,7 @@
                 <a:solidFill>
                   <a:srgbClr val="C9CFD8"/>
                 </a:solidFill>
-                <a:latin typeface="Segoe UI"/>
+                <a:latin typeface="Rubik"/>
               </a:rPr>
               <a:t>всем имуществом</a:t>
             </a:r>
@@ -5325,7 +5325,7 @@
                 <a:solidFill>
                   <a:srgbClr val="C9CFD8"/>
                 </a:solidFill>
-                <a:latin typeface="Segoe UI"/>
+                <a:latin typeface="Rubik"/>
               </a:rPr>
               <a:t>в пределах вклада</a:t>
             </a:r>
@@ -5395,11 +5395,11 @@
               </a:lnSpc>
             </a:pPr>
             <a:r>
-              <a:rPr sz="1250" b="0">
+              <a:rPr sz="1250" b="1">
                 <a:solidFill>
                   <a:srgbClr val="FFFFFF"/>
                 </a:solidFill>
-                <a:latin typeface="Segoe UI Semibold"/>
+                <a:latin typeface="Rubik"/>
               </a:rPr>
               <a:t>Доли между 5 участниками</a:t>
             </a:r>
@@ -5438,7 +5438,7 @@
                 <a:solidFill>
                   <a:srgbClr val="C9CFD8"/>
                 </a:solidFill>
-                <a:latin typeface="Segoe UI"/>
+                <a:latin typeface="Rubik"/>
               </a:rPr>
               <a:t>нельзя</a:t>
             </a:r>
@@ -5477,7 +5477,7 @@
                 <a:solidFill>
                   <a:srgbClr val="C9CFD8"/>
                 </a:solidFill>
-                <a:latin typeface="Segoe UI"/>
+                <a:latin typeface="Rubik"/>
               </a:rPr>
               <a:t>20% × 5</a:t>
             </a:r>
@@ -5547,11 +5547,11 @@
               </a:lnSpc>
             </a:pPr>
             <a:r>
-              <a:rPr sz="1250" b="0">
+              <a:rPr sz="1250" b="1">
                 <a:solidFill>
                   <a:srgbClr val="FFFFFF"/>
                 </a:solidFill>
-                <a:latin typeface="Segoe UI Semibold"/>
+                <a:latin typeface="Rubik"/>
               </a:rPr>
               <a:t>Инвестиции и опционы</a:t>
             </a:r>
@@ -5590,7 +5590,7 @@
                 <a:solidFill>
                   <a:srgbClr val="C9CFD8"/>
                 </a:solidFill>
-                <a:latin typeface="Segoe UI"/>
+                <a:latin typeface="Rubik"/>
               </a:rPr>
               <a:t>нет</a:t>
             </a:r>
@@ -5629,7 +5629,7 @@
                 <a:solidFill>
                   <a:srgbClr val="C9CFD8"/>
                 </a:solidFill>
-                <a:latin typeface="Segoe UI"/>
+                <a:latin typeface="Rubik"/>
               </a:rPr>
               <a:t>да</a:t>
             </a:r>
@@ -5699,11 +5699,11 @@
               </a:lnSpc>
             </a:pPr>
             <a:r>
-              <a:rPr sz="1250" b="0">
+              <a:rPr sz="1250" b="1">
                 <a:solidFill>
                   <a:srgbClr val="FFFFFF"/>
                 </a:solidFill>
-                <a:latin typeface="Segoe UI Semibold"/>
+                <a:latin typeface="Rubik"/>
               </a:rPr>
               <a:t>Права на ИС и знак</a:t>
             </a:r>
@@ -5742,7 +5742,7 @@
                 <a:solidFill>
                   <a:srgbClr val="C9CFD8"/>
                 </a:solidFill>
-                <a:latin typeface="Segoe UI"/>
+                <a:latin typeface="Rubik"/>
               </a:rPr>
               <a:t>на физлице</a:t>
             </a:r>
@@ -5781,7 +5781,7 @@
                 <a:solidFill>
                   <a:srgbClr val="C9CFD8"/>
                 </a:solidFill>
-                <a:latin typeface="Segoe UI"/>
+                <a:latin typeface="Rubik"/>
               </a:rPr>
               <a:t>на компанию</a:t>
             </a:r>
@@ -5851,11 +5851,11 @@
               </a:lnSpc>
             </a:pPr>
             <a:r>
-              <a:rPr sz="1250" b="0">
+              <a:rPr sz="1250" b="1">
                 <a:solidFill>
                   <a:srgbClr val="FFFFFF"/>
                 </a:solidFill>
-                <a:latin typeface="Segoe UI Semibold"/>
+                <a:latin typeface="Rubik"/>
               </a:rPr>
               <a:t>Стоимость ведения</a:t>
             </a:r>
@@ -5894,7 +5894,7 @@
                 <a:solidFill>
                   <a:srgbClr val="C9CFD8"/>
                 </a:solidFill>
-                <a:latin typeface="Segoe UI"/>
+                <a:latin typeface="Rubik"/>
               </a:rPr>
               <a:t>≈ 0 ₽</a:t>
             </a:r>
@@ -5933,7 +5933,7 @@
                 <a:solidFill>
                   <a:srgbClr val="C9CFD8"/>
                 </a:solidFill>
-                <a:latin typeface="Segoe UI"/>
+                <a:latin typeface="Rubik"/>
               </a:rPr>
               <a:t>от 5 000 ₽/мес</a:t>
             </a:r>
@@ -6055,7 +6055,7 @@
                 <a:solidFill>
                   <a:srgbClr val="2BDD93"/>
                 </a:solidFill>
-                <a:latin typeface="Segoe UI"/>
+                <a:latin typeface="Rubik"/>
               </a:rPr>
               <a:t>РЕШЕНИЕ</a:t>
             </a:r>
@@ -6097,16 +6097,16 @@
                 <a:solidFill>
                   <a:srgbClr val="2BDD93"/>
                 </a:solidFill>
-                <a:latin typeface="Segoe UI"/>
-              </a:rPr>
-              <a:t>▪  </a:t>
+                <a:latin typeface="Rubik"/>
+              </a:rPr>
+              <a:t>•  </a:t>
             </a:r>
             <a:r>
               <a:rPr sz="1250">
                 <a:solidFill>
                   <a:srgbClr val="2BDD93"/>
                 </a:solidFill>
-                <a:latin typeface="Segoe UI"/>
+                <a:latin typeface="Rubik"/>
               </a:rPr>
               <a:t>АО избыточно для старта (форма для IPO и крупных раундов)</a:t>
             </a:r>
@@ -6125,18 +6125,18 @@
                 <a:solidFill>
                   <a:srgbClr val="2BDD93"/>
                 </a:solidFill>
-                <a:latin typeface="Segoe UI"/>
-              </a:rPr>
-              <a:t>▪  </a:t>
+                <a:latin typeface="Rubik"/>
+              </a:rPr>
+              <a:t>•  </a:t>
             </a:r>
             <a:r>
               <a:rPr sz="1250">
                 <a:solidFill>
                   <a:srgbClr val="2BDD93"/>
                 </a:solidFill>
-                <a:latin typeface="Segoe UI"/>
-              </a:rPr>
-              <a:t>ИП уже встроено в расчёты недели 7 — менять нечего</a:t>
+                <a:latin typeface="Rubik"/>
+              </a:rPr>
+              <a:t>ИП уже встроено в расчёты недели 7 — менять нечего</a:t>
             </a:r>
           </a:p>
           <a:p>
@@ -6153,16 +6153,16 @@
                 <a:solidFill>
                   <a:srgbClr val="2BDD93"/>
                 </a:solidFill>
-                <a:latin typeface="Segoe UI"/>
-              </a:rPr>
-              <a:t>▪  </a:t>
+                <a:latin typeface="Rubik"/>
+              </a:rPr>
+              <a:t>•  </a:t>
             </a:r>
             <a:r>
               <a:rPr sz="1250">
                 <a:solidFill>
                   <a:srgbClr val="2BDD93"/>
                 </a:solidFill>
-                <a:latin typeface="Segoe UI"/>
+                <a:latin typeface="Rubik"/>
               </a:rPr>
               <a:t>ООО не создаёт ценности при выручке ≈ 0, но обязывает к отчётности</a:t>
             </a:r>
@@ -6181,16 +6181,16 @@
                 <a:solidFill>
                   <a:srgbClr val="2BDD93"/>
                 </a:solidFill>
-                <a:latin typeface="Segoe UI"/>
-              </a:rPr>
-              <a:t>▪  </a:t>
+                <a:latin typeface="Rubik"/>
+              </a:rPr>
+              <a:t>•  </a:t>
             </a:r>
             <a:r>
               <a:rPr sz="1250">
                 <a:solidFill>
                   <a:srgbClr val="2BDD93"/>
                 </a:solidFill>
-                <a:latin typeface="Segoe UI"/>
+                <a:latin typeface="Rubik"/>
               </a:rPr>
               <a:t>Вывод: ИП сейчас, ООО — событийно, по триггеру</a:t>
             </a:r>
@@ -6255,7 +6255,7 @@
                 <a:solidFill>
                   <a:srgbClr val="7A899F"/>
                 </a:solidFill>
-                <a:latin typeface="Segoe UI"/>
+                <a:latin typeface="Rubik"/>
               </a:rPr>
               <a:t>ЗАДАНИЕ 1 · МОДЕЛЬ</a:t>
             </a:r>
@@ -6290,13 +6290,13 @@
               </a:lnSpc>
             </a:pPr>
             <a:r>
-              <a:rPr sz="3000" b="0">
+              <a:rPr sz="3000" b="1">
                 <a:solidFill>
                   <a:srgbClr val="FFFFFF"/>
                 </a:solidFill>
-                <a:latin typeface="Segoe UI Semibold"/>
-              </a:rPr>
-              <a:t>ИП сейчас → ООО по триггеру</a:t>
+                <a:latin typeface="Rubik"/>
+              </a:rPr>
+              <a:t>От ИП к ООО — по триггеру</a:t>
             </a:r>
           </a:p>
         </p:txBody>
@@ -6329,11 +6329,11 @@
               </a:lnSpc>
             </a:pPr>
             <a:r>
-              <a:rPr sz="1000" b="0">
+              <a:rPr sz="1000" b="1">
                 <a:solidFill>
                   <a:srgbClr val="2BDD93"/>
                 </a:solidFill>
-                <a:latin typeface="Segoe UI Semibold"/>
+                <a:latin typeface="Rubik"/>
               </a:rPr>
               <a:t>PiConstruct  ·  ПЗ №16 · правовая база стартапа</a:t>
             </a:r>
@@ -6372,7 +6372,7 @@
                 <a:solidFill>
                   <a:srgbClr val="7A899F"/>
                 </a:solidFill>
-                <a:latin typeface="Segoe UI"/>
+                <a:latin typeface="Rubik"/>
               </a:rPr>
               <a:t>3 / 10</a:t>
             </a:r>
@@ -6459,7 +6459,7 @@
                 <a:solidFill>
                   <a:srgbClr val="7A899F"/>
                 </a:solidFill>
-                <a:latin typeface="Segoe UI"/>
+                <a:latin typeface="Rubik"/>
               </a:rPr>
               <a:t>ЭТАП 1 · СЕЙЧАС</a:t>
             </a:r>
@@ -6494,11 +6494,11 @@
               </a:lnSpc>
             </a:pPr>
             <a:r>
-              <a:rPr sz="1700" b="0">
+              <a:rPr sz="1700" b="1">
                 <a:solidFill>
                   <a:srgbClr val="FFFFFF"/>
                 </a:solidFill>
-                <a:latin typeface="Segoe UI Semibold"/>
+                <a:latin typeface="Rubik"/>
               </a:rPr>
               <a:t>ИП тимлида на УСН «доходы» 6%</a:t>
             </a:r>
@@ -6540,18 +6540,18 @@
                 <a:solidFill>
                   <a:srgbClr val="2BDD93"/>
                 </a:solidFill>
-                <a:latin typeface="Segoe UI"/>
-              </a:rPr>
-              <a:t>▪  </a:t>
+                <a:latin typeface="Rubik"/>
+              </a:rPr>
+              <a:t>•  </a:t>
             </a:r>
             <a:r>
               <a:rPr sz="1150">
                 <a:solidFill>
                   <a:srgbClr val="2BDD93"/>
                 </a:solidFill>
-                <a:latin typeface="Segoe UI"/>
-              </a:rPr>
-              <a:t>приём платежей РФ и от партнёра в Казахстане — из юнит-экономики недели 7</a:t>
+                <a:latin typeface="Rubik"/>
+              </a:rPr>
+              <a:t>приём платежей РФ и от партнёра в Казахстане — из юнит-экономики недели 7</a:t>
             </a:r>
           </a:p>
           <a:p>
@@ -6568,16 +6568,16 @@
                 <a:solidFill>
                   <a:srgbClr val="2BDD93"/>
                 </a:solidFill>
-                <a:latin typeface="Segoe UI"/>
-              </a:rPr>
-              <a:t>▪  </a:t>
+                <a:latin typeface="Rubik"/>
+              </a:rPr>
+              <a:t>•  </a:t>
             </a:r>
             <a:r>
               <a:rPr sz="1150">
                 <a:solidFill>
                   <a:srgbClr val="2BDD93"/>
                 </a:solidFill>
-                <a:latin typeface="Segoe UI"/>
+                <a:latin typeface="Rubik"/>
               </a:rPr>
               <a:t>отчётность минимальна, регистрация электронно — без пошлины</a:t>
             </a:r>
@@ -6596,16 +6596,16 @@
                 <a:solidFill>
                   <a:srgbClr val="2BDD93"/>
                 </a:solidFill>
-                <a:latin typeface="Segoe UI"/>
-              </a:rPr>
-              <a:t>▪  </a:t>
+                <a:latin typeface="Rubik"/>
+              </a:rPr>
+              <a:t>•  </a:t>
             </a:r>
             <a:r>
               <a:rPr sz="1150">
                 <a:solidFill>
                   <a:srgbClr val="2BDD93"/>
                 </a:solidFill>
-                <a:latin typeface="Segoe UI"/>
+                <a:latin typeface="Rubik"/>
               </a:rPr>
               <a:t>минус ИП (нет долей) компенсирует партнёрское соглашение — задание №3</a:t>
             </a:r>
@@ -6692,7 +6692,7 @@
                 <a:solidFill>
                   <a:srgbClr val="7A899F"/>
                 </a:solidFill>
-                <a:latin typeface="Segoe UI"/>
+                <a:latin typeface="Rubik"/>
               </a:rPr>
               <a:t>ЭТАП 2 · ПО ТРИГГЕРУ</a:t>
             </a:r>
@@ -6727,11 +6727,11 @@
               </a:lnSpc>
             </a:pPr>
             <a:r>
-              <a:rPr sz="1700" b="0">
+              <a:rPr sz="1700" b="1">
                 <a:solidFill>
                   <a:srgbClr val="FFFFFF"/>
                 </a:solidFill>
-                <a:latin typeface="Segoe UI Semibold"/>
+                <a:latin typeface="Rubik"/>
               </a:rPr>
               <a:t>ООО: доли 20% × 5, УК 50 000 ₽</a:t>
             </a:r>
@@ -6773,16 +6773,16 @@
                 <a:solidFill>
                   <a:srgbClr val="2BDD93"/>
                 </a:solidFill>
-                <a:latin typeface="Segoe UI"/>
-              </a:rPr>
-              <a:t>▪  </a:t>
+                <a:latin typeface="Rubik"/>
+              </a:rPr>
+              <a:t>•  </a:t>
             </a:r>
             <a:r>
               <a:rPr sz="1150">
                 <a:solidFill>
                   <a:srgbClr val="2BDD93"/>
                 </a:solidFill>
-                <a:latin typeface="Segoe UI"/>
+                <a:latin typeface="Rubik"/>
               </a:rPr>
               <a:t>генеральный директор — тимлид; решения большинством 3 из 5</a:t>
             </a:r>
@@ -6801,16 +6801,16 @@
                 <a:solidFill>
                   <a:srgbClr val="2BDD93"/>
                 </a:solidFill>
-                <a:latin typeface="Segoe UI"/>
-              </a:rPr>
-              <a:t>▪  </a:t>
+                <a:latin typeface="Rubik"/>
+              </a:rPr>
+              <a:t>•  </a:t>
             </a:r>
             <a:r>
               <a:rPr sz="1150">
                 <a:solidFill>
                   <a:srgbClr val="2BDD93"/>
                 </a:solidFill>
-                <a:latin typeface="Segoe UI"/>
+                <a:latin typeface="Rubik"/>
               </a:rPr>
               <a:t>УСН «доходы» 6% — модель недель 7 и 14 не меняется</a:t>
             </a:r>
@@ -6829,18 +6829,18 @@
                 <a:solidFill>
                   <a:srgbClr val="2BDD93"/>
                 </a:solidFill>
-                <a:latin typeface="Segoe UI"/>
-              </a:rPr>
-              <a:t>▪  </a:t>
+                <a:latin typeface="Rubik"/>
+              </a:rPr>
+              <a:t>•  </a:t>
             </a:r>
             <a:r>
               <a:rPr sz="1150">
                 <a:solidFill>
                   <a:srgbClr val="2BDD93"/>
                 </a:solidFill>
-                <a:latin typeface="Segoe UI"/>
-              </a:rPr>
-              <a:t>регистрация через сервис ФНС электронно — пошлина 0 ₽ (ст. 333.35 НК РФ)</a:t>
+                <a:latin typeface="Rubik"/>
+              </a:rPr>
+              <a:t>регистрация через сервис ФНС электронно — пошлина 0 ₽ (ст. 333.35 НК РФ)</a:t>
             </a:r>
           </a:p>
         </p:txBody>
@@ -6925,7 +6925,7 @@
                 <a:solidFill>
                   <a:srgbClr val="2BDD93"/>
                 </a:solidFill>
-                <a:latin typeface="Segoe UI"/>
+                <a:latin typeface="Rubik"/>
               </a:rPr>
               <a:t>ТРИГГЕР</a:t>
             </a:r>
@@ -6964,7 +6964,7 @@
                 <a:solidFill>
                   <a:srgbClr val="C9CFD8"/>
                 </a:solidFill>
-                <a:latin typeface="Segoe UI"/>
+                <a:latin typeface="Rubik"/>
               </a:rPr>
               <a:t>Выручка ≥ 30 000 ₽/мес три месяца подряд (~12 покупок Pro в месяц) — либо инвестор/грант, либо первый наём в штат.</a:t>
             </a:r>
@@ -6980,7 +6980,7 @@
                 <a:solidFill>
                   <a:srgbClr val="C9CFD8"/>
                 </a:solidFill>
-                <a:latin typeface="Segoe UI"/>
+                <a:latin typeface="Rubik"/>
               </a:rPr>
               <a:t>При такой выручке бухгалтерия (≈ 5 000 ₽/мес) ≤ 17% дохода, а 90 000 ₽ за три месяца покрывают сопровождение и половину пошлин знака.</a:t>
             </a:r>
@@ -7045,7 +7045,7 @@
                 <a:solidFill>
                   <a:srgbClr val="7A899F"/>
                 </a:solidFill>
-                <a:latin typeface="Segoe UI"/>
+                <a:latin typeface="Rubik"/>
               </a:rPr>
               <a:t>ЗАДАНИЕ 1 · УПРАВЛЕНИЕ И ОТВЕТСТВЕННОСТЬ</a:t>
             </a:r>
@@ -7080,13 +7080,13 @@
               </a:lnSpc>
             </a:pPr>
             <a:r>
-              <a:rPr sz="3000" b="0">
+              <a:rPr sz="3000" b="1">
                 <a:solidFill>
                   <a:srgbClr val="FFFFFF"/>
                 </a:solidFill>
-                <a:latin typeface="Segoe UI Semibold"/>
-              </a:rPr>
-              <a:t>3 из 5 по текущим вопросам, единогласно — по ключевым</a:t>
+                <a:latin typeface="Rubik"/>
+              </a:rPr>
+              <a:t>Текущие — 3 из 5, ключевые — единогласно</a:t>
             </a:r>
           </a:p>
         </p:txBody>
@@ -7119,11 +7119,11 @@
               </a:lnSpc>
             </a:pPr>
             <a:r>
-              <a:rPr sz="1000" b="0">
+              <a:rPr sz="1000" b="1">
                 <a:solidFill>
                   <a:srgbClr val="2BDD93"/>
                 </a:solidFill>
-                <a:latin typeface="Segoe UI Semibold"/>
+                <a:latin typeface="Rubik"/>
               </a:rPr>
               <a:t>PiConstruct  ·  ПЗ №16 · правовая база стартапа</a:t>
             </a:r>
@@ -7162,7 +7162,7 @@
                 <a:solidFill>
                   <a:srgbClr val="7A899F"/>
                 </a:solidFill>
-                <a:latin typeface="Segoe UI"/>
+                <a:latin typeface="Rubik"/>
               </a:rPr>
               <a:t>4 / 10</a:t>
             </a:r>
@@ -7249,7 +7249,7 @@
                 <a:solidFill>
                   <a:srgbClr val="2BDD93"/>
                 </a:solidFill>
-                <a:latin typeface="Segoe UI"/>
+                <a:latin typeface="Rubik"/>
               </a:rPr>
               <a:t>БОЛЬШИНСТВО · 3 ИЗ 5</a:t>
             </a:r>
@@ -7291,16 +7291,16 @@
                 <a:solidFill>
                   <a:srgbClr val="2BDD93"/>
                 </a:solidFill>
-                <a:latin typeface="Segoe UI"/>
-              </a:rPr>
-              <a:t>▪  </a:t>
+                <a:latin typeface="Rubik"/>
+              </a:rPr>
+              <a:t>•  </a:t>
             </a:r>
             <a:r>
               <a:rPr sz="1150">
                 <a:solidFill>
                   <a:srgbClr val="2BDD93"/>
                 </a:solidFill>
-                <a:latin typeface="Segoe UI"/>
+                <a:latin typeface="Rubik"/>
               </a:rPr>
               <a:t>операционный бюджет до 500 000 ₽/квартал</a:t>
             </a:r>
@@ -7319,16 +7319,16 @@
                 <a:solidFill>
                   <a:srgbClr val="2BDD93"/>
                 </a:solidFill>
-                <a:latin typeface="Segoe UI"/>
-              </a:rPr>
-              <a:t>▪  </a:t>
+                <a:latin typeface="Rubik"/>
+              </a:rPr>
+              <a:t>•  </a:t>
             </a:r>
             <a:r>
               <a:rPr sz="1150">
                 <a:solidFill>
                   <a:srgbClr val="2BDD93"/>
                 </a:solidFill>
-                <a:latin typeface="Segoe UI"/>
+                <a:latin typeface="Rubik"/>
               </a:rPr>
               <a:t>цены в рамках стратегии, найм исполнителей</a:t>
             </a:r>
@@ -7347,16 +7347,16 @@
                 <a:solidFill>
                   <a:srgbClr val="2BDD93"/>
                 </a:solidFill>
-                <a:latin typeface="Segoe UI"/>
-              </a:rPr>
-              <a:t>▪  </a:t>
+                <a:latin typeface="Rubik"/>
+              </a:rPr>
+              <a:t>•  </a:t>
             </a:r>
             <a:r>
               <a:rPr sz="1150">
                 <a:solidFill>
                   <a:srgbClr val="2BDD93"/>
                 </a:solidFill>
-                <a:latin typeface="Segoe UI"/>
+                <a:latin typeface="Rubik"/>
               </a:rPr>
               <a:t>пять голосов — нечётное число: тупик невозможен</a:t>
             </a:r>
@@ -7443,7 +7443,7 @@
                 <a:solidFill>
                   <a:srgbClr val="2BDD93"/>
                 </a:solidFill>
-                <a:latin typeface="Segoe UI"/>
+                <a:latin typeface="Rubik"/>
               </a:rPr>
               <a:t>ЕДИНОГЛАСНО · 5 ИЗ 5</a:t>
             </a:r>
@@ -7485,16 +7485,16 @@
                 <a:solidFill>
                   <a:srgbClr val="2BDD93"/>
                 </a:solidFill>
-                <a:latin typeface="Segoe UI"/>
-              </a:rPr>
-              <a:t>▪  </a:t>
+                <a:latin typeface="Rubik"/>
+              </a:rPr>
+              <a:t>•  </a:t>
             </a:r>
             <a:r>
               <a:rPr sz="1150">
                 <a:solidFill>
                   <a:srgbClr val="2BDD93"/>
                 </a:solidFill>
-                <a:latin typeface="Segoe UI"/>
+                <a:latin typeface="Rubik"/>
               </a:rPr>
               <a:t>приём и выход участников, продажа долей вовне</a:t>
             </a:r>
@@ -7513,16 +7513,16 @@
                 <a:solidFill>
                   <a:srgbClr val="2BDD93"/>
                 </a:solidFill>
-                <a:latin typeface="Segoe UI"/>
-              </a:rPr>
-              <a:t>▪  </a:t>
+                <a:latin typeface="Rubik"/>
+              </a:rPr>
+              <a:t>•  </a:t>
             </a:r>
             <a:r>
               <a:rPr sz="1150">
                 <a:solidFill>
                   <a:srgbClr val="2BDD93"/>
                 </a:solidFill>
-                <a:latin typeface="Segoe UI"/>
+                <a:latin typeface="Rubik"/>
               </a:rPr>
               <a:t>ликвидация, финансирование с размыванием долей</a:t>
             </a:r>
@@ -7541,16 +7541,16 @@
                 <a:solidFill>
                   <a:srgbClr val="2BDD93"/>
                 </a:solidFill>
-                <a:latin typeface="Segoe UI"/>
-              </a:rPr>
-              <a:t>▪  </a:t>
+                <a:latin typeface="Rubik"/>
+              </a:rPr>
+              <a:t>•  </a:t>
             </a:r>
             <a:r>
               <a:rPr sz="1150">
                 <a:solidFill>
                   <a:srgbClr val="2BDD93"/>
                 </a:solidFill>
-                <a:latin typeface="Segoe UI"/>
+                <a:latin typeface="Rubik"/>
               </a:rPr>
               <a:t>сделки свыше 500 000 ₽, смена продуктового направления</a:t>
             </a:r>
@@ -7637,7 +7637,7 @@
                 <a:solidFill>
                   <a:srgbClr val="7A899F"/>
                 </a:solidFill>
-                <a:latin typeface="Segoe UI"/>
+                <a:latin typeface="Rubik"/>
               </a:rPr>
               <a:t>ОТВЕТСТВЕННОСТЬ</a:t>
             </a:r>
@@ -7679,16 +7679,16 @@
                 <a:solidFill>
                   <a:srgbClr val="C9CFD8"/>
                 </a:solidFill>
-                <a:latin typeface="Segoe UI"/>
-              </a:rPr>
-              <a:t>▪  </a:t>
+                <a:latin typeface="Rubik"/>
+              </a:rPr>
+              <a:t>•  </a:t>
             </a:r>
             <a:r>
               <a:rPr sz="1150">
                 <a:solidFill>
                   <a:srgbClr val="C9CFD8"/>
                 </a:solidFill>
-                <a:latin typeface="Segoe UI"/>
+                <a:latin typeface="Rubik"/>
               </a:rPr>
               <a:t>ИП (сейчас) — всем личным имуществом: этап короткий</a:t>
             </a:r>
@@ -7707,16 +7707,16 @@
                 <a:solidFill>
                   <a:srgbClr val="C9CFD8"/>
                 </a:solidFill>
-                <a:latin typeface="Segoe UI"/>
-              </a:rPr>
-              <a:t>▪  </a:t>
+                <a:latin typeface="Rubik"/>
+              </a:rPr>
+              <a:t>•  </a:t>
             </a:r>
             <a:r>
               <a:rPr sz="1150">
                 <a:solidFill>
                   <a:srgbClr val="C9CFD8"/>
                 </a:solidFill>
-                <a:latin typeface="Segoe UI"/>
+                <a:latin typeface="Rubik"/>
               </a:rPr>
               <a:t>ООО — в пределах вкладов; гендиректор — субсидиарная при виновном банкротстве</a:t>
             </a:r>
@@ -7803,7 +7803,7 @@
                 <a:solidFill>
                   <a:srgbClr val="2CABDD"/>
                 </a:solidFill>
-                <a:latin typeface="Segoe UI"/>
+                <a:latin typeface="Rubik"/>
               </a:rPr>
               <a:t>ВЕСТИНГ ДОЛЕЙ</a:t>
             </a:r>
@@ -7838,11 +7838,11 @@
               </a:lnSpc>
             </a:pPr>
             <a:r>
-              <a:rPr sz="1500" b="0">
+              <a:rPr sz="1500" b="1">
                 <a:solidFill>
                   <a:srgbClr val="FFFFFF"/>
                 </a:solidFill>
-                <a:latin typeface="Segoe UI Semibold"/>
+                <a:latin typeface="Rubik"/>
               </a:rPr>
               <a:t>4 года · клифф 12 месяцев</a:t>
             </a:r>
@@ -7881,7 +7881,7 @@
                 <a:solidFill>
                   <a:srgbClr val="C9CFD8"/>
                 </a:solidFill>
-                <a:latin typeface="Segoe UI"/>
+                <a:latin typeface="Rubik"/>
               </a:rPr>
               <a:t>далее — по 1/48 доли в месяц; при выходе раньше невестированная часть возвращается команде (механика — слайд 8)</a:t>
             </a:r>
@@ -7946,7 +7946,7 @@
                 <a:solidFill>
                   <a:srgbClr val="7A899F"/>
                 </a:solidFill>
-                <a:latin typeface="Segoe UI"/>
+                <a:latin typeface="Rubik"/>
               </a:rPr>
               <a:t>ЗАДАНИЕ 2 · ИНТЕЛЛЕКТУАЛЬНАЯ СОБСТВЕННОСТЬ</a:t>
             </a:r>
@@ -7981,11 +7981,11 @@
               </a:lnSpc>
             </a:pPr>
             <a:r>
-              <a:rPr sz="3000" b="0">
+              <a:rPr sz="3000" b="1">
                 <a:solidFill>
                   <a:srgbClr val="FFFFFF"/>
                 </a:solidFill>
-                <a:latin typeface="Segoe UI Semibold"/>
+                <a:latin typeface="Rubik"/>
               </a:rPr>
               <a:t>Карта активов: что и чем защищаем</a:t>
             </a:r>
@@ -8020,11 +8020,11 @@
               </a:lnSpc>
             </a:pPr>
             <a:r>
-              <a:rPr sz="1000" b="0">
+              <a:rPr sz="1000" b="1">
                 <a:solidFill>
                   <a:srgbClr val="2BDD93"/>
                 </a:solidFill>
-                <a:latin typeface="Segoe UI Semibold"/>
+                <a:latin typeface="Rubik"/>
               </a:rPr>
               <a:t>PiConstruct  ·  ПЗ №16 · правовая база стартапа</a:t>
             </a:r>
@@ -8063,7 +8063,7 @@
                 <a:solidFill>
                   <a:srgbClr val="7A899F"/>
                 </a:solidFill>
-                <a:latin typeface="Segoe UI"/>
+                <a:latin typeface="Rubik"/>
               </a:rPr>
               <a:t>5 / 10</a:t>
             </a:r>
@@ -8146,11 +8146,11 @@
               </a:lnSpc>
             </a:pPr>
             <a:r>
-              <a:rPr sz="1150" b="0">
+              <a:rPr sz="1150" b="1">
                 <a:solidFill>
                   <a:srgbClr val="7A899F"/>
                 </a:solidFill>
-                <a:latin typeface="Segoe UI Semibold"/>
+                <a:latin typeface="Rubik"/>
               </a:rPr>
               <a:t>Актив</a:t>
             </a:r>
@@ -8185,11 +8185,11 @@
               </a:lnSpc>
             </a:pPr>
             <a:r>
-              <a:rPr sz="1150" b="0">
+              <a:rPr sz="1150" b="1">
                 <a:solidFill>
                   <a:srgbClr val="7A899F"/>
                 </a:solidFill>
-                <a:latin typeface="Segoe UI Semibold"/>
+                <a:latin typeface="Rubik"/>
               </a:rPr>
               <a:t>Режим охраны</a:t>
             </a:r>
@@ -8224,11 +8224,11 @@
               </a:lnSpc>
             </a:pPr>
             <a:r>
-              <a:rPr sz="1150" b="0">
+              <a:rPr sz="1150" b="1">
                 <a:solidFill>
                   <a:srgbClr val="7A899F"/>
                 </a:solidFill>
-                <a:latin typeface="Segoe UI Semibold"/>
+                <a:latin typeface="Rubik"/>
               </a:rPr>
               <a:t>Действие команды</a:t>
             </a:r>
@@ -8298,11 +8298,11 @@
               </a:lnSpc>
             </a:pPr>
             <a:r>
-              <a:rPr sz="1250" b="0">
+              <a:rPr sz="1250" b="1">
                 <a:solidFill>
                   <a:srgbClr val="FFFFFF"/>
                 </a:solidFill>
-                <a:latin typeface="Segoe UI Semibold"/>
+                <a:latin typeface="Rubik"/>
               </a:rPr>
               <a:t>Код конструктора, сервера, сборщика</a:t>
             </a:r>
@@ -8341,7 +8341,7 @@
                 <a:solidFill>
                   <a:srgbClr val="C9CFD8"/>
                 </a:solidFill>
-                <a:latin typeface="Segoe UI"/>
+                <a:latin typeface="Rubik"/>
               </a:rPr>
               <a:t>авторское право — автоматически</a:t>
             </a:r>
@@ -8380,7 +8380,7 @@
                 <a:solidFill>
                   <a:srgbClr val="C9CFD8"/>
                 </a:solidFill>
-                <a:latin typeface="Segoe UI"/>
+                <a:latin typeface="Rubik"/>
               </a:rPr>
               <a:t>5 договоров отчуждения на ИП</a:t>
             </a:r>
@@ -8450,11 +8450,11 @@
               </a:lnSpc>
             </a:pPr>
             <a:r>
-              <a:rPr sz="1250" b="0">
+              <a:rPr sz="1250" b="1">
                 <a:solidFill>
                   <a:srgbClr val="FFFFFF"/>
                 </a:solidFill>
-                <a:latin typeface="Segoe UI Semibold"/>
+                <a:latin typeface="Rubik"/>
               </a:rPr>
               <a:t>Дизайн-система и логотип</a:t>
             </a:r>
@@ -8493,7 +8493,7 @@
                 <a:solidFill>
                   <a:srgbClr val="C9CFD8"/>
                 </a:solidFill>
-                <a:latin typeface="Segoe UI"/>
+                <a:latin typeface="Rubik"/>
               </a:rPr>
               <a:t>авторское право + товарный знак</a:t>
             </a:r>
@@ -8532,7 +8532,7 @@
                 <a:solidFill>
                   <a:srgbClr val="C9CFD8"/>
                 </a:solidFill>
-                <a:latin typeface="Segoe UI"/>
+                <a:latin typeface="Rubik"/>
               </a:rPr>
               <a:t>заявка на знак после регистрации ООО</a:t>
             </a:r>
@@ -8602,11 +8602,11 @@
               </a:lnSpc>
             </a:pPr>
             <a:r>
-              <a:rPr sz="1250" b="0">
+              <a:rPr sz="1250" b="1">
                 <a:solidFill>
                   <a:srgbClr val="FFFFFF"/>
                 </a:solidFill>
-                <a:latin typeface="Segoe UI Semibold"/>
+                <a:latin typeface="Rubik"/>
               </a:rPr>
               <a:t>Образ .img на базе FullPageOS</a:t>
             </a:r>
@@ -8645,7 +8645,7 @@
                 <a:solidFill>
                   <a:srgbClr val="C9CFD8"/>
                 </a:solidFill>
-                <a:latin typeface="Segoe UI"/>
+                <a:latin typeface="Rubik"/>
               </a:rPr>
               <a:t>GPL-3.0 (copyleft)</a:t>
             </a:r>
@@ -8684,7 +8684,7 @@
                 <a:solidFill>
                   <a:srgbClr val="C9CFD8"/>
                 </a:solidFill>
-                <a:latin typeface="Segoe UI"/>
+                <a:latin typeface="Rubik"/>
               </a:rPr>
               <a:t>публиковать исходники сборки образа</a:t>
             </a:r>
@@ -8754,11 +8754,11 @@
               </a:lnSpc>
             </a:pPr>
             <a:r>
-              <a:rPr sz="1250" b="0">
+              <a:rPr sz="1250" b="1">
                 <a:solidFill>
                   <a:srgbClr val="FFFFFF"/>
                 </a:solidFill>
-                <a:latin typeface="Segoe UI Semibold"/>
+                <a:latin typeface="Rubik"/>
               </a:rPr>
               <a:t>Бренд: имя, домены, канал</a:t>
             </a:r>
@@ -8797,7 +8797,7 @@
                 <a:solidFill>
                   <a:srgbClr val="C9CFD8"/>
                 </a:solidFill>
-                <a:latin typeface="Segoe UI"/>
+                <a:latin typeface="Rubik"/>
               </a:rPr>
               <a:t>товарный знак, МКТУ 09/42/35</a:t>
             </a:r>
@@ -8836,7 +8836,7 @@
                 <a:solidFill>
                   <a:srgbClr val="C9CFD8"/>
                 </a:solidFill>
-                <a:latin typeface="Segoe UI"/>
+                <a:latin typeface="Rubik"/>
               </a:rPr>
               <a:t>piconstruct.ru свободен — регистрировать</a:t>
             </a:r>
@@ -8906,11 +8906,11 @@
               </a:lnSpc>
             </a:pPr>
             <a:r>
-              <a:rPr sz="1250" b="0">
+              <a:rPr sz="1250" b="1">
                 <a:solidFill>
                   <a:srgbClr val="FFFFFF"/>
                 </a:solidFill>
-                <a:latin typeface="Segoe UI Semibold"/>
+                <a:latin typeface="Rubik"/>
               </a:rPr>
               <a:t>Персональные данные (лендинг)</a:t>
             </a:r>
@@ -8949,7 +8949,7 @@
                 <a:solidFill>
                   <a:srgbClr val="C9CFD8"/>
                 </a:solidFill>
-                <a:latin typeface="Segoe UI"/>
+                <a:latin typeface="Rubik"/>
               </a:rPr>
               <a:t>ФЗ-152</a:t>
             </a:r>
@@ -8988,7 +8988,7 @@
                 <a:solidFill>
                   <a:srgbClr val="C9CFD8"/>
                 </a:solidFill>
-                <a:latin typeface="Segoe UI"/>
+                <a:latin typeface="Rubik"/>
               </a:rPr>
               <a:t>уведомление РКН, реквизиты оператора</a:t>
             </a:r>
@@ -9058,11 +9058,11 @@
               </a:lnSpc>
             </a:pPr>
             <a:r>
-              <a:rPr sz="1250" b="0">
+              <a:rPr sz="1250" b="1">
                 <a:solidFill>
                   <a:srgbClr val="FFFFFF"/>
                 </a:solidFill>
-                <a:latin typeface="Segoe UI Semibold"/>
+                <a:latin typeface="Rubik"/>
               </a:rPr>
               <a:t>Контент клиентов (меню)</a:t>
             </a:r>
@@ -9101,7 +9101,7 @@
                 <a:solidFill>
                   <a:srgbClr val="C9CFD8"/>
                 </a:solidFill>
-                <a:latin typeface="Segoe UI"/>
+                <a:latin typeface="Rubik"/>
               </a:rPr>
               <a:t>права клиента</a:t>
             </a:r>
@@ -9140,7 +9140,7 @@
                 <a:solidFill>
                   <a:srgbClr val="C9CFD8"/>
                 </a:solidFill>
-                <a:latin typeface="Segoe UI"/>
+                <a:latin typeface="Rubik"/>
               </a:rPr>
               <a:t>пользовательское соглашение (оферта)</a:t>
             </a:r>
@@ -9240,7 +9240,7 @@
                 <a:solidFill>
                   <a:srgbClr val="7A899F"/>
                 </a:solidFill>
-                <a:latin typeface="Segoe UI"/>
+                <a:latin typeface="Rubik"/>
               </a:rPr>
               <a:t>ЗАДАНИЕ 2 · ПЛАН ЗАЩИТЫ</a:t>
             </a:r>
@@ -9275,11 +9275,11 @@
               </a:lnSpc>
             </a:pPr>
             <a:r>
-              <a:rPr sz="3000" b="0">
+              <a:rPr sz="3000" b="1">
                 <a:solidFill>
                   <a:srgbClr val="FFFFFF"/>
                 </a:solidFill>
-                <a:latin typeface="Segoe UI Semibold"/>
+                <a:latin typeface="Rubik"/>
               </a:rPr>
               <a:t>Дорожная карта юридического оформления</a:t>
             </a:r>
@@ -9314,11 +9314,11 @@
               </a:lnSpc>
             </a:pPr>
             <a:r>
-              <a:rPr sz="1000" b="0">
+              <a:rPr sz="1000" b="1">
                 <a:solidFill>
                   <a:srgbClr val="2BDD93"/>
                 </a:solidFill>
-                <a:latin typeface="Segoe UI Semibold"/>
+                <a:latin typeface="Rubik"/>
               </a:rPr>
               <a:t>PiConstruct  ·  ПЗ №16 · правовая база стартапа</a:t>
             </a:r>
@@ -9357,7 +9357,7 @@
                 <a:solidFill>
                   <a:srgbClr val="7A899F"/>
                 </a:solidFill>
-                <a:latin typeface="Segoe UI"/>
+                <a:latin typeface="Rubik"/>
               </a:rPr>
               <a:t>6 / 10</a:t>
             </a:r>
@@ -9440,11 +9440,11 @@
               </a:lnSpc>
             </a:pPr>
             <a:r>
-              <a:rPr sz="1450" b="0">
+              <a:rPr sz="1450" b="1">
                 <a:solidFill>
                   <a:srgbClr val="FFFFFF"/>
                 </a:solidFill>
-                <a:latin typeface="Segoe UI Semibold"/>
+                <a:latin typeface="Rubik"/>
               </a:rPr>
               <a:t>Ноябрь 2026</a:t>
             </a:r>
@@ -9486,16 +9486,16 @@
                 <a:solidFill>
                   <a:srgbClr val="2BDD93"/>
                 </a:solidFill>
-                <a:latin typeface="Segoe UI"/>
-              </a:rPr>
-              <a:t>▪  </a:t>
+                <a:latin typeface="Rubik"/>
+              </a:rPr>
+              <a:t>•  </a:t>
             </a:r>
             <a:r>
               <a:rPr sz="1100">
                 <a:solidFill>
                   <a:srgbClr val="2BDD93"/>
                 </a:solidFill>
-                <a:latin typeface="Segoe UI"/>
+                <a:latin typeface="Rubik"/>
               </a:rPr>
               <a:t>партнёрское соглашение — 0 ₽</a:t>
             </a:r>
@@ -9514,16 +9514,16 @@
                 <a:solidFill>
                   <a:srgbClr val="2BDD93"/>
                 </a:solidFill>
-                <a:latin typeface="Segoe UI"/>
-              </a:rPr>
-              <a:t>▪  </a:t>
+                <a:latin typeface="Rubik"/>
+              </a:rPr>
+              <a:t>•  </a:t>
             </a:r>
             <a:r>
               <a:rPr sz="1100">
                 <a:solidFill>
                   <a:srgbClr val="2BDD93"/>
                 </a:solidFill>
-                <a:latin typeface="Segoe UI"/>
+                <a:latin typeface="Rubik"/>
               </a:rPr>
               <a:t>5 договоров отчуждения прав</a:t>
             </a:r>
@@ -9542,18 +9542,18 @@
                 <a:solidFill>
                   <a:srgbClr val="2BDD93"/>
                 </a:solidFill>
-                <a:latin typeface="Segoe UI"/>
-              </a:rPr>
-              <a:t>▪  </a:t>
+                <a:latin typeface="Rubik"/>
+              </a:rPr>
+              <a:t>•  </a:t>
             </a:r>
             <a:r>
               <a:rPr sz="1100">
                 <a:solidFill>
                   <a:srgbClr val="2BDD93"/>
                 </a:solidFill>
-                <a:latin typeface="Segoe UI"/>
-              </a:rPr>
-              <a:t>NDA для переговоров с партнёром (фаза 0 недели 7)</a:t>
+                <a:latin typeface="Rubik"/>
+              </a:rPr>
+              <a:t>NDA для переговоров с партнёром (фаза 0 недели 7)</a:t>
             </a:r>
           </a:p>
         </p:txBody>
@@ -9634,11 +9634,11 @@
               </a:lnSpc>
             </a:pPr>
             <a:r>
-              <a:rPr sz="1450" b="0">
+              <a:rPr sz="1450" b="1">
                 <a:solidFill>
                   <a:srgbClr val="FFFFFF"/>
                 </a:solidFill>
-                <a:latin typeface="Segoe UI Semibold"/>
+                <a:latin typeface="Rubik"/>
               </a:rPr>
               <a:t>До онлайн-платежей</a:t>
             </a:r>
@@ -9680,16 +9680,16 @@
                 <a:solidFill>
                   <a:srgbClr val="2BDD93"/>
                 </a:solidFill>
-                <a:latin typeface="Segoe UI"/>
-              </a:rPr>
-              <a:t>▪  </a:t>
+                <a:latin typeface="Rubik"/>
+              </a:rPr>
+              <a:t>•  </a:t>
             </a:r>
             <a:r>
               <a:rPr sz="1100">
                 <a:solidFill>
                   <a:srgbClr val="2BDD93"/>
                 </a:solidFill>
-                <a:latin typeface="Segoe UI"/>
+                <a:latin typeface="Rubik"/>
               </a:rPr>
               <a:t>уведомление Роскомнадзора — 0 ₽</a:t>
             </a:r>
@@ -9708,16 +9708,16 @@
                 <a:solidFill>
                   <a:srgbClr val="2BDD93"/>
                 </a:solidFill>
-                <a:latin typeface="Segoe UI"/>
-              </a:rPr>
-              <a:t>▪  </a:t>
+                <a:latin typeface="Rubik"/>
+              </a:rPr>
+              <a:t>•  </a:t>
             </a:r>
             <a:r>
               <a:rPr sz="1100">
                 <a:solidFill>
                   <a:srgbClr val="2BDD93"/>
                 </a:solidFill>
-                <a:latin typeface="Segoe UI"/>
+                <a:latin typeface="Rubik"/>
               </a:rPr>
               <a:t>реквизиты оператора в политике</a:t>
             </a:r>
@@ -9736,16 +9736,16 @@
                 <a:solidFill>
                   <a:srgbClr val="2BDD93"/>
                 </a:solidFill>
-                <a:latin typeface="Segoe UI"/>
-              </a:rPr>
-              <a:t>▪  </a:t>
+                <a:latin typeface="Rubik"/>
+              </a:rPr>
+              <a:t>•  </a:t>
             </a:r>
             <a:r>
               <a:rPr sz="1100">
                 <a:solidFill>
                   <a:srgbClr val="2BDD93"/>
                 </a:solidFill>
-                <a:latin typeface="Segoe UI"/>
+                <a:latin typeface="Rubik"/>
               </a:rPr>
               <a:t>пользовательское соглашение на лендинг</a:t>
             </a:r>
@@ -9828,11 +9828,11 @@
               </a:lnSpc>
             </a:pPr>
             <a:r>
-              <a:rPr sz="1450" b="0">
+              <a:rPr sz="1450" b="1">
                 <a:solidFill>
                   <a:srgbClr val="FFFFFF"/>
                 </a:solidFill>
-                <a:latin typeface="Segoe UI Semibold"/>
+                <a:latin typeface="Rubik"/>
               </a:rPr>
               <a:t>Регистрация ООО</a:t>
             </a:r>
@@ -9874,16 +9874,16 @@
                 <a:solidFill>
                   <a:srgbClr val="2BDD93"/>
                 </a:solidFill>
-                <a:latin typeface="Segoe UI"/>
-              </a:rPr>
-              <a:t>▪  </a:t>
+                <a:latin typeface="Rubik"/>
+              </a:rPr>
+              <a:t>•  </a:t>
             </a:r>
             <a:r>
               <a:rPr sz="1100">
                 <a:solidFill>
                   <a:srgbClr val="2BDD93"/>
                 </a:solidFill>
-                <a:latin typeface="Segoe UI"/>
+                <a:latin typeface="Rubik"/>
               </a:rPr>
               <a:t>переоформление ИС с ИП на ООО</a:t>
             </a:r>
@@ -9902,16 +9902,16 @@
                 <a:solidFill>
                   <a:srgbClr val="2BDD93"/>
                 </a:solidFill>
-                <a:latin typeface="Segoe UI"/>
-              </a:rPr>
-              <a:t>▪  </a:t>
+                <a:latin typeface="Rubik"/>
+              </a:rPr>
+              <a:t>•  </a:t>
             </a:r>
             <a:r>
               <a:rPr sz="1100">
                 <a:solidFill>
                   <a:srgbClr val="2BDD93"/>
                 </a:solidFill>
-                <a:latin typeface="Segoe UI"/>
+                <a:latin typeface="Rubik"/>
               </a:rPr>
               <a:t>устав + корпоративный договор</a:t>
             </a:r>
@@ -9930,16 +9930,16 @@
                 <a:solidFill>
                   <a:srgbClr val="2BDD93"/>
                 </a:solidFill>
-                <a:latin typeface="Segoe UI"/>
-              </a:rPr>
-              <a:t>▪  </a:t>
+                <a:latin typeface="Rubik"/>
+              </a:rPr>
+              <a:t>•  </a:t>
             </a:r>
             <a:r>
               <a:rPr sz="1100">
                 <a:solidFill>
                   <a:srgbClr val="2BDD93"/>
                 </a:solidFill>
-                <a:latin typeface="Segoe UI"/>
+                <a:latin typeface="Rubik"/>
               </a:rPr>
               <a:t>пошлина 0 ₽ при подаче электронно</a:t>
             </a:r>
@@ -10022,11 +10022,11 @@
               </a:lnSpc>
             </a:pPr>
             <a:r>
-              <a:rPr sz="1450" b="0">
+              <a:rPr sz="1450" b="1">
                 <a:solidFill>
                   <a:srgbClr val="FFFFFF"/>
                 </a:solidFill>
-                <a:latin typeface="Segoe UI Semibold"/>
+                <a:latin typeface="Rubik"/>
               </a:rPr>
               <a:t>+1–⁠2 месяца · знак</a:t>
             </a:r>
@@ -10068,16 +10068,16 @@
                 <a:solidFill>
                   <a:srgbClr val="2BDD93"/>
                 </a:solidFill>
-                <a:latin typeface="Segoe UI"/>
-              </a:rPr>
-              <a:t>▪  </a:t>
+                <a:latin typeface="Rubik"/>
+              </a:rPr>
+              <a:t>•  </a:t>
             </a:r>
             <a:r>
               <a:rPr sz="1100">
                 <a:solidFill>
                   <a:srgbClr val="2BDD93"/>
                 </a:solidFill>
-                <a:latin typeface="Segoe UI"/>
+                <a:latin typeface="Rubik"/>
               </a:rPr>
               <a:t>проверка ФИПС и TMview</a:t>
             </a:r>
@@ -10096,16 +10096,16 @@
                 <a:solidFill>
                   <a:srgbClr val="2BDD93"/>
                 </a:solidFill>
-                <a:latin typeface="Segoe UI"/>
-              </a:rPr>
-              <a:t>▪  </a:t>
+                <a:latin typeface="Rubik"/>
+              </a:rPr>
+              <a:t>•  </a:t>
             </a:r>
             <a:r>
               <a:rPr sz="1100">
                 <a:solidFill>
                   <a:srgbClr val="2BDD93"/>
                 </a:solidFill>
-                <a:latin typeface="Segoe UI"/>
+                <a:latin typeface="Rubik"/>
               </a:rPr>
               <a:t>заявка: 3 класса МКТУ — 42 000 ₽</a:t>
             </a:r>
@@ -10124,18 +10124,18 @@
                 <a:solidFill>
                   <a:srgbClr val="2BDD93"/>
                 </a:solidFill>
-                <a:latin typeface="Segoe UI"/>
-              </a:rPr>
-              <a:t>▪  </a:t>
+                <a:latin typeface="Rubik"/>
+              </a:rPr>
+              <a:t>•  </a:t>
             </a:r>
             <a:r>
               <a:rPr sz="1100">
                 <a:solidFill>
                   <a:srgbClr val="2BDD93"/>
                 </a:solidFill>
-                <a:latin typeface="Segoe UI"/>
-              </a:rPr>
-              <a:t>свидетельство через 8–⁠12 месяцев</a:t>
+                <a:latin typeface="Rubik"/>
+              </a:rPr>
+              <a:t>свидетельство — от 8 до 12 месяцев</a:t>
             </a:r>
           </a:p>
         </p:txBody>
@@ -10220,7 +10220,7 @@
                 <a:solidFill>
                   <a:srgbClr val="2BDD93"/>
                 </a:solidFill>
-                <a:latin typeface="Segoe UI"/>
+                <a:latin typeface="Rubik"/>
               </a:rPr>
               <a:t>ПРАВИЛО</a:t>
             </a:r>
@@ -10259,9 +10259,9 @@
                 <a:solidFill>
                   <a:srgbClr val="C9CFD8"/>
                 </a:solidFill>
-                <a:latin typeface="Segoe UI"/>
-              </a:rPr>
-              <a:t>Все исключительные права — у компании, не у физлиц: участники — договоры отчуждения (ст. 1234 ГК РФ), сотрудники — служебные произведения (ст. 1295), подрядчики — условие в договоре подряда.</a:t>
+                <a:latin typeface="Rubik"/>
+              </a:rPr>
+              <a:t>Все исключительные права — у компании, не у физлиц: участники — договоры отчуждения (ст. 1234 ГК РФ), сотрудники — служебные произведения (ст. 1295), подрядчики — условие в договоре подряда.</a:t>
             </a:r>
           </a:p>
         </p:txBody>
@@ -10324,7 +10324,7 @@
                 <a:solidFill>
                   <a:srgbClr val="7A899F"/>
                 </a:solidFill>
-                <a:latin typeface="Segoe UI"/>
+                <a:latin typeface="Rubik"/>
               </a:rPr>
               <a:t>ЗАДАНИЕ 3 · ТИПОВОЙ ДОГОВОР</a:t>
             </a:r>
@@ -10359,11 +10359,11 @@
               </a:lnSpc>
             </a:pPr>
             <a:r>
-              <a:rPr sz="3000" b="0">
+              <a:rPr sz="3000" b="1">
                 <a:solidFill>
                   <a:srgbClr val="FFFFFF"/>
                 </a:solidFill>
-                <a:latin typeface="Segoe UI Semibold"/>
+                <a:latin typeface="Rubik"/>
               </a:rPr>
               <a:t>Партнёрское соглашение: главный риск закрыт</a:t>
             </a:r>
@@ -10398,11 +10398,11 @@
               </a:lnSpc>
             </a:pPr>
             <a:r>
-              <a:rPr sz="1000" b="0">
+              <a:rPr sz="1000" b="1">
                 <a:solidFill>
                   <a:srgbClr val="2BDD93"/>
                 </a:solidFill>
-                <a:latin typeface="Segoe UI Semibold"/>
+                <a:latin typeface="Rubik"/>
               </a:rPr>
               <a:t>PiConstruct  ·  ПЗ №16 · правовая база стартапа</a:t>
             </a:r>
@@ -10441,7 +10441,7 @@
                 <a:solidFill>
                   <a:srgbClr val="7A899F"/>
                 </a:solidFill>
-                <a:latin typeface="Segoe UI"/>
+                <a:latin typeface="Rubik"/>
               </a:rPr>
               <a:t>7 / 10</a:t>
             </a:r>
@@ -10528,7 +10528,7 @@
                 <a:solidFill>
                   <a:srgbClr val="2BDD93"/>
                 </a:solidFill>
-                <a:latin typeface="Segoe UI"/>
+                <a:latin typeface="Rubik"/>
               </a:rPr>
               <a:t>ПОЧЕМУ ИМЕННО ОНО</a:t>
             </a:r>
@@ -10570,16 +10570,16 @@
                 <a:solidFill>
                   <a:srgbClr val="2BDD93"/>
                 </a:solidFill>
-                <a:latin typeface="Segoe UI"/>
-              </a:rPr>
-              <a:t>▪  </a:t>
+                <a:latin typeface="Rubik"/>
+              </a:rPr>
+              <a:t>•  </a:t>
             </a:r>
             <a:r>
               <a:rPr sz="1200">
                 <a:solidFill>
                   <a:srgbClr val="2BDD93"/>
                 </a:solidFill>
-                <a:latin typeface="Segoe UI"/>
+                <a:latin typeface="Rubik"/>
               </a:rPr>
               <a:t>доли, роли и правила выхода не зафиксированы нигде — а продукт уже продаётся</a:t>
             </a:r>
@@ -10598,16 +10598,16 @@
                 <a:solidFill>
                   <a:srgbClr val="2BDD93"/>
                 </a:solidFill>
-                <a:latin typeface="Segoe UI"/>
-              </a:rPr>
-              <a:t>▪  </a:t>
+                <a:latin typeface="Rubik"/>
+              </a:rPr>
+              <a:t>•  </a:t>
             </a:r>
             <a:r>
               <a:rPr sz="1200">
                 <a:solidFill>
                   <a:srgbClr val="2BDD93"/>
                 </a:solidFill>
-                <a:latin typeface="Segoe UI"/>
+                <a:latin typeface="Rubik"/>
               </a:rPr>
               <a:t>бизнес на одном ИП при продукте, созданном пятью: без соглашения код остаётся у авторов</a:t>
             </a:r>
@@ -10626,18 +10626,18 @@
                 <a:solidFill>
                   <a:srgbClr val="2BDD93"/>
                 </a:solidFill>
-                <a:latin typeface="Segoe UI"/>
-              </a:rPr>
-              <a:t>▪  </a:t>
+                <a:latin typeface="Rubik"/>
+              </a:rPr>
+              <a:t>•  </a:t>
             </a:r>
             <a:r>
               <a:rPr sz="1200">
                 <a:solidFill>
                   <a:srgbClr val="2BDD93"/>
                 </a:solidFill>
-                <a:latin typeface="Segoe UI"/>
-              </a:rPr>
-              <a:t>до ООО действует как простое товарищество (ст. 1041 ГК РФ), после — переносится в устав и корпоративный договор</a:t>
+                <a:latin typeface="Rubik"/>
+              </a:rPr>
+              <a:t>до ООО действует как простое товарищество (ст. 1041 ГК РФ), после — переносится в устав и корпоративный договор</a:t>
             </a:r>
           </a:p>
           <a:p>
@@ -10654,16 +10654,16 @@
                 <a:solidFill>
                   <a:srgbClr val="2BDD93"/>
                 </a:solidFill>
-                <a:latin typeface="Segoe UI"/>
-              </a:rPr>
-              <a:t>▪  </a:t>
+                <a:latin typeface="Rubik"/>
+              </a:rPr>
+              <a:t>•  </a:t>
             </a:r>
             <a:r>
               <a:rPr sz="1200">
                 <a:solidFill>
                   <a:srgbClr val="2BDD93"/>
                 </a:solidFill>
-                <a:latin typeface="Segoe UI"/>
+                <a:latin typeface="Rubik"/>
               </a:rPr>
               <a:t>прототип — 11 разделов, готов к проверке юристом</a:t>
             </a:r>
@@ -10750,7 +10750,7 @@
                 <a:solidFill>
                   <a:srgbClr val="2BDD93"/>
                 </a:solidFill>
-                <a:latin typeface="Segoe UI"/>
+                <a:latin typeface="Rubik"/>
               </a:rPr>
               <a:t>СТРУКТУРА ПРОТОТИПА</a:t>
             </a:r>
@@ -10792,7 +10792,7 @@
                 <a:solidFill>
                   <a:srgbClr val="C9CFD8"/>
                 </a:solidFill>
-                <a:latin typeface="Segoe UI"/>
+                <a:latin typeface="Rubik"/>
               </a:rPr>
               <a:t>1. Стороны и предмет</a:t>
             </a:r>
@@ -10811,7 +10811,7 @@
                 <a:solidFill>
                   <a:srgbClr val="C9CFD8"/>
                 </a:solidFill>
-                <a:latin typeface="Segoe UI"/>
+                <a:latin typeface="Rubik"/>
               </a:rPr>
               <a:t>2. Вклады и доли — по 20%</a:t>
             </a:r>
@@ -10830,9 +10830,9 @@
                 <a:solidFill>
                   <a:srgbClr val="C9CFD8"/>
                 </a:solidFill>
-                <a:latin typeface="Segoe UI"/>
-              </a:rPr>
-              <a:t>3. Роли и ответственность (RACI недели 14)</a:t>
+                <a:latin typeface="Rubik"/>
+              </a:rPr>
+              <a:t>3. Роли и ответственность (RACI недели 14)</a:t>
             </a:r>
           </a:p>
           <a:p>
@@ -10849,7 +10849,7 @@
                 <a:solidFill>
                   <a:srgbClr val="C9CFD8"/>
                 </a:solidFill>
-                <a:latin typeface="Segoe UI"/>
+                <a:latin typeface="Rubik"/>
               </a:rPr>
               <a:t>4. Вестинг — 4 года, клифф 12 мес.</a:t>
             </a:r>
@@ -10868,7 +10868,7 @@
                 <a:solidFill>
                   <a:srgbClr val="C9CFD8"/>
                 </a:solidFill>
-                <a:latin typeface="Segoe UI"/>
+                <a:latin typeface="Rubik"/>
               </a:rPr>
               <a:t>5. Принятие решений — 3/5 и единогласно</a:t>
             </a:r>
@@ -10887,7 +10887,7 @@
                 <a:solidFill>
                   <a:srgbClr val="C9CFD8"/>
                 </a:solidFill>
-                <a:latin typeface="Segoe UI"/>
+                <a:latin typeface="Rubik"/>
               </a:rPr>
               <a:t>6. Конкуренция и конфиденциальность</a:t>
             </a:r>
@@ -10906,7 +10906,7 @@
                 <a:solidFill>
                   <a:srgbClr val="C9CFD8"/>
                 </a:solidFill>
-                <a:latin typeface="Segoe UI"/>
+                <a:latin typeface="Rubik"/>
               </a:rPr>
               <a:t>7. Интеллектуальная собственность</a:t>
             </a:r>
@@ -10925,7 +10925,7 @@
                 <a:solidFill>
                   <a:srgbClr val="C9CFD8"/>
                 </a:solidFill>
-                <a:latin typeface="Segoe UI"/>
+                <a:latin typeface="Rubik"/>
               </a:rPr>
               <a:t>8. Выход и выкуп доли</a:t>
             </a:r>
@@ -10944,7 +10944,7 @@
                 <a:solidFill>
                   <a:srgbClr val="C9CFD8"/>
                 </a:solidFill>
-                <a:latin typeface="Segoe UI"/>
+                <a:latin typeface="Rubik"/>
               </a:rPr>
               <a:t>9. Прибыль и расходы</a:t>
             </a:r>
@@ -10963,7 +10963,7 @@
                 <a:solidFill>
                   <a:srgbClr val="C9CFD8"/>
                 </a:solidFill>
-                <a:latin typeface="Segoe UI"/>
+                <a:latin typeface="Rubik"/>
               </a:rPr>
               <a:t>10. Разрешение споров</a:t>
             </a:r>
@@ -10982,7 +10982,7 @@
                 <a:solidFill>
                   <a:srgbClr val="C9CFD8"/>
                 </a:solidFill>
-                <a:latin typeface="Segoe UI"/>
+                <a:latin typeface="Rubik"/>
               </a:rPr>
               <a:t>11. Перенос в устав и корпоративный договор</a:t>
             </a:r>
@@ -11047,7 +11047,7 @@
                 <a:solidFill>
                   <a:srgbClr val="7A899F"/>
                 </a:solidFill>
-                <a:latin typeface="Segoe UI"/>
+                <a:latin typeface="Rubik"/>
               </a:rPr>
               <a:t>ЗАДАНИЕ 3 · КЛЮЧЕВЫЕ ПОЛОЖЕНИЯ</a:t>
             </a:r>
@@ -11082,11 +11082,11 @@
               </a:lnSpc>
             </a:pPr>
             <a:r>
-              <a:rPr sz="3000" b="0">
+              <a:rPr sz="3000" b="1">
                 <a:solidFill>
                   <a:srgbClr val="FFFFFF"/>
                 </a:solidFill>
-                <a:latin typeface="Segoe UI Semibold"/>
+                <a:latin typeface="Rubik"/>
               </a:rPr>
               <a:t>Доли, решения, выход: пять опор соглашения</a:t>
             </a:r>
@@ -11121,11 +11121,11 @@
               </a:lnSpc>
             </a:pPr>
             <a:r>
-              <a:rPr sz="1000" b="0">
+              <a:rPr sz="1000" b="1">
                 <a:solidFill>
                   <a:srgbClr val="2BDD93"/>
                 </a:solidFill>
-                <a:latin typeface="Segoe UI Semibold"/>
+                <a:latin typeface="Rubik"/>
               </a:rPr>
               <a:t>PiConstruct  ·  ПЗ №16 · правовая база стартапа</a:t>
             </a:r>
@@ -11164,7 +11164,7 @@
                 <a:solidFill>
                   <a:srgbClr val="7A899F"/>
                 </a:solidFill>
-                <a:latin typeface="Segoe UI"/>
+                <a:latin typeface="Rubik"/>
               </a:rPr>
               <a:t>8 / 10</a:t>
             </a:r>
@@ -11247,11 +11247,11 @@
               </a:lnSpc>
             </a:pPr>
             <a:r>
-              <a:rPr sz="1400" b="0">
+              <a:rPr sz="1400" b="1">
                 <a:solidFill>
                   <a:srgbClr val="2BDD93"/>
                 </a:solidFill>
-                <a:latin typeface="Segoe UI Semibold"/>
+                <a:latin typeface="Rubik"/>
               </a:rPr>
               <a:t>20% × 5 + вестинг</a:t>
             </a:r>
@@ -11290,7 +11290,7 @@
                 <a:solidFill>
                   <a:srgbClr val="C9CFD8"/>
                 </a:solidFill>
-                <a:latin typeface="Segoe UI"/>
+                <a:latin typeface="Rubik"/>
               </a:rPr>
               <a:t>равные доли; закрепление — 4 года с клиффом 12 месяцев: уходит раньше — доля возвращается команде</a:t>
             </a:r>
@@ -11373,11 +11373,11 @@
               </a:lnSpc>
             </a:pPr>
             <a:r>
-              <a:rPr sz="1400" b="0">
+              <a:rPr sz="1400" b="1">
                 <a:solidFill>
                   <a:srgbClr val="2BDD93"/>
                 </a:solidFill>
-                <a:latin typeface="Segoe UI Semibold"/>
+                <a:latin typeface="Rubik"/>
               </a:rPr>
               <a:t>Решения 3/5</a:t>
             </a:r>
@@ -11416,7 +11416,7 @@
                 <a:solidFill>
                   <a:srgbClr val="C9CFD8"/>
                 </a:solidFill>
-                <a:latin typeface="Segoe UI"/>
+                <a:latin typeface="Rubik"/>
               </a:rPr>
               <a:t>текущие — большинством, тупик исключён; ключевые (продажа долей, размывание, сделки &gt; 500 000 ₽) — единогласно</a:t>
             </a:r>
@@ -11499,11 +11499,11 @@
               </a:lnSpc>
             </a:pPr>
             <a:r>
-              <a:rPr sz="1400" b="0">
+              <a:rPr sz="1400" b="1">
                 <a:solidFill>
                   <a:srgbClr val="2BDD93"/>
                 </a:solidFill>
-                <a:latin typeface="Segoe UI Semibold"/>
+                <a:latin typeface="Rubik"/>
               </a:rPr>
               <a:t>ИС — компании</a:t>
             </a:r>
@@ -11542,9 +11542,9 @@
                 <a:solidFill>
                   <a:srgbClr val="C9CFD8"/>
                 </a:solidFill>
-                <a:latin typeface="Segoe UI"/>
-              </a:rPr>
-              <a:t>всё созданное в проекте отчуждается по ст. 1234 ГК РФ; авторство остаётся за участниками</a:t>
+                <a:latin typeface="Rubik"/>
+              </a:rPr>
+              <a:t>всё созданное в проекте отчуждается по ст. 1234 ГК РФ; авторство остаётся за участниками</a:t>
             </a:r>
           </a:p>
         </p:txBody>
@@ -11625,11 +11625,11 @@
               </a:lnSpc>
             </a:pPr>
             <a:r>
-              <a:rPr sz="1400" b="0">
+              <a:rPr sz="1400" b="1">
                 <a:solidFill>
                   <a:srgbClr val="2BDD93"/>
                 </a:solidFill>
-                <a:latin typeface="Segoe UI Semibold"/>
+                <a:latin typeface="Rubik"/>
               </a:rPr>
               <a:t>Выход через ROFR</a:t>
             </a:r>
@@ -11668,7 +11668,7 @@
                 <a:solidFill>
                   <a:srgbClr val="C9CFD8"/>
                 </a:solidFill>
-                <a:latin typeface="Segoe UI"/>
+                <a:latin typeface="Rubik"/>
               </a:rPr>
               <a:t>вестированная доля — по оценке с преимуществом для сооснователей; невестированная — по номиналу</a:t>
             </a:r>
@@ -11751,11 +11751,11 @@
               </a:lnSpc>
             </a:pPr>
             <a:r>
-              <a:rPr sz="1400" b="0">
+              <a:rPr sz="1400" b="1">
                 <a:solidFill>
                   <a:srgbClr val="2BDD93"/>
                 </a:solidFill>
-                <a:latin typeface="Segoe UI Semibold"/>
+                <a:latin typeface="Rubik"/>
               </a:rPr>
               <a:t>Неконкуренция</a:t>
             </a:r>
@@ -11794,7 +11794,7 @@
                 <a:solidFill>
                   <a:srgbClr val="C9CFD8"/>
                 </a:solidFill>
-                <a:latin typeface="Segoe UI"/>
+                <a:latin typeface="Rubik"/>
               </a:rPr>
               <a:t>запрет конкурирующих проектов в нише digital signage — во время участия и 12 месяцев после выхода</a:t>
             </a:r>
@@ -11881,7 +11881,7 @@
                 <a:solidFill>
                   <a:srgbClr val="2CABDD"/>
                 </a:solidFill>
-                <a:latin typeface="Segoe UI"/>
+                <a:latin typeface="Rubik"/>
               </a:rPr>
               <a:t>МЕХАНИКА В РФ</a:t>
             </a:r>
@@ -11920,9 +11920,9 @@
                 <a:solidFill>
                   <a:srgbClr val="C9CFD8"/>
                 </a:solidFill>
-                <a:latin typeface="Segoe UI"/>
-              </a:rPr>
-              <a:t>«Автоматического» вестинга в российском праве нет: обязательство продать долю закрепляют корпоративным договором и опционами (ст. 429.2 ГК РФ), сами сделки с долями — нотариальные (ст. 21 ФЗ «Об ООО»).</a:t>
+                <a:latin typeface="Rubik"/>
+              </a:rPr>
+              <a:t>«Автоматического» вестинга в российском праве нет: обязательство продать долю закрепляют корпоративным договором и опционами (ст. 429.2 ГК РФ), сами сделки с долями — нотариальные (ст. 21 ФЗ «Об ООО»).</a:t>
             </a:r>
           </a:p>
         </p:txBody>
@@ -11985,7 +11985,7 @@
                 <a:solidFill>
                   <a:srgbClr val="7A899F"/>
                 </a:solidFill>
-                <a:latin typeface="Segoe UI"/>
+                <a:latin typeface="Rubik"/>
               </a:rPr>
               <a:t>ОБСУЖДЕНИЕ · ТИПИЧНЫЕ ОШИБКИ</a:t>
             </a:r>
@@ -12020,11 +12020,11 @@
               </a:lnSpc>
             </a:pPr>
             <a:r>
-              <a:rPr sz="3000" b="0">
+              <a:rPr sz="3000" b="1">
                 <a:solidFill>
                   <a:srgbClr val="FFFFFF"/>
                 </a:solidFill>
-                <a:latin typeface="Segoe UI Semibold"/>
+                <a:latin typeface="Rubik"/>
               </a:rPr>
               <a:t>Ошибки стартапов и наша защита</a:t>
             </a:r>
@@ -12059,11 +12059,11 @@
               </a:lnSpc>
             </a:pPr>
             <a:r>
-              <a:rPr sz="1000" b="0">
+              <a:rPr sz="1000" b="1">
                 <a:solidFill>
                   <a:srgbClr val="2BDD93"/>
                 </a:solidFill>
-                <a:latin typeface="Segoe UI Semibold"/>
+                <a:latin typeface="Rubik"/>
               </a:rPr>
               <a:t>PiConstruct  ·  ПЗ №16 · правовая база стартапа</a:t>
             </a:r>
@@ -12102,7 +12102,7 @@
                 <a:solidFill>
                   <a:srgbClr val="7A899F"/>
                 </a:solidFill>
-                <a:latin typeface="Segoe UI"/>
+                <a:latin typeface="Rubik"/>
               </a:rPr>
               <a:t>9 / 10</a:t>
             </a:r>
@@ -12185,11 +12185,11 @@
               </a:lnSpc>
             </a:pPr>
             <a:r>
-              <a:rPr sz="1150" b="0">
+              <a:rPr sz="1150" b="1">
                 <a:solidFill>
                   <a:srgbClr val="7A899F"/>
                 </a:solidFill>
-                <a:latin typeface="Segoe UI Semibold"/>
+                <a:latin typeface="Rubik"/>
               </a:rPr>
               <a:t>Типичная ошибка</a:t>
             </a:r>
@@ -12224,11 +12224,11 @@
               </a:lnSpc>
             </a:pPr>
             <a:r>
-              <a:rPr sz="1150" b="0">
+              <a:rPr sz="1150" b="1">
                 <a:solidFill>
                   <a:srgbClr val="7A899F"/>
                 </a:solidFill>
-                <a:latin typeface="Segoe UI Semibold"/>
+                <a:latin typeface="Rubik"/>
               </a:rPr>
               <a:t>Как закрыто у нас</a:t>
             </a:r>
@@ -12298,11 +12298,11 @@
               </a:lnSpc>
             </a:pPr>
             <a:r>
-              <a:rPr sz="1250" b="0">
+              <a:rPr sz="1250" b="1">
                 <a:solidFill>
                   <a:srgbClr val="FFFFFF"/>
                 </a:solidFill>
-                <a:latin typeface="Segoe UI Semibold"/>
+                <a:latin typeface="Rubik"/>
               </a:rPr>
               <a:t>Бизнес на одном ИП, продукт создан командой</a:t>
             </a:r>
@@ -12341,7 +12341,7 @@
                 <a:solidFill>
                   <a:srgbClr val="C9CFD8"/>
                 </a:solidFill>
-                <a:latin typeface="Segoe UI"/>
+                <a:latin typeface="Rubik"/>
               </a:rPr>
               <a:t>партнёрское соглашение + 5 договоров отчуждения до внешних переговоров</a:t>
             </a:r>
@@ -12411,11 +12411,11 @@
               </a:lnSpc>
             </a:pPr>
             <a:r>
-              <a:rPr sz="1250" b="0">
+              <a:rPr sz="1250" b="1">
                 <a:solidFill>
                   <a:srgbClr val="FFFFFF"/>
                 </a:solidFill>
-                <a:latin typeface="Segoe UI Semibold"/>
+                <a:latin typeface="Rubik"/>
               </a:rPr>
               <a:t>Равные доли без вестинга</a:t>
             </a:r>
@@ -12454,7 +12454,7 @@
                 <a:solidFill>
                   <a:srgbClr val="C9CFD8"/>
                 </a:solidFill>
-                <a:latin typeface="Segoe UI"/>
+                <a:latin typeface="Rubik"/>
               </a:rPr>
               <a:t>вестинг 4 года / клифф 12 месяцев (раздел 4 прототипа)</a:t>
             </a:r>
@@ -12524,11 +12524,11 @@
               </a:lnSpc>
             </a:pPr>
             <a:r>
-              <a:rPr sz="1250" b="0">
+              <a:rPr sz="1250" b="1">
                 <a:solidFill>
                   <a:srgbClr val="FFFFFF"/>
                 </a:solidFill>
-                <a:latin typeface="Segoe UI Semibold"/>
+                <a:latin typeface="Rubik"/>
               </a:rPr>
               <a:t>Знак не проверен до подачи</a:t>
             </a:r>
@@ -12567,7 +12567,7 @@
                 <a:solidFill>
                   <a:srgbClr val="C9CFD8"/>
                 </a:solidFill>
-                <a:latin typeface="Segoe UI"/>
+                <a:latin typeface="Rubik"/>
               </a:rPr>
               <a:t>базы ФИПС и TMview + домен piconstruct.ru до заявки</a:t>
             </a:r>
@@ -12637,11 +12637,11 @@
               </a:lnSpc>
             </a:pPr>
             <a:r>
-              <a:rPr sz="1250" b="0">
+              <a:rPr sz="1250" b="1">
                 <a:solidFill>
                   <a:srgbClr val="FFFFFF"/>
                 </a:solidFill>
-                <a:latin typeface="Segoe UI Semibold"/>
+                <a:latin typeface="Rubik"/>
               </a:rPr>
               <a:t>GPL-образ без исходников</a:t>
             </a:r>
@@ -12680,7 +12680,7 @@
                 <a:solidFill>
                   <a:srgbClr val="C9CFD8"/>
                 </a:solidFill>
-                <a:latin typeface="Segoe UI"/>
+                <a:latin typeface="Rubik"/>
               </a:rPr>
               <a:t>публикация скриптов сборки, страница «Открытый код»</a:t>
             </a:r>
@@ -12750,11 +12750,11 @@
               </a:lnSpc>
             </a:pPr>
             <a:r>
-              <a:rPr sz="1250" b="0">
+              <a:rPr sz="1250" b="1">
                 <a:solidFill>
                   <a:srgbClr val="FFFFFF"/>
                 </a:solidFill>
-                <a:latin typeface="Segoe UI Semibold"/>
+                <a:latin typeface="Rubik"/>
               </a:rPr>
               <a:t>Данные без уведомления РКН</a:t>
             </a:r>
@@ -12793,7 +12793,7 @@
                 <a:solidFill>
                   <a:srgbClr val="C9CFD8"/>
                 </a:solidFill>
-                <a:latin typeface="Segoe UI"/>
+                <a:latin typeface="Rubik"/>
               </a:rPr>
               <a:t>уведомление при регистрации оператора; согласия уже собраны</a:t>
             </a:r>
@@ -12863,11 +12863,11 @@
               </a:lnSpc>
             </a:pPr>
             <a:r>
-              <a:rPr sz="1250" b="0">
+              <a:rPr sz="1250" b="1">
                 <a:solidFill>
                   <a:srgbClr val="FFFFFF"/>
                 </a:solidFill>
-                <a:latin typeface="Segoe UI Semibold"/>
+                <a:latin typeface="Rubik"/>
               </a:rPr>
               <a:t>Устные договорённости с подрядчиками</a:t>
             </a:r>
@@ -12906,9 +12906,9 @@
                 <a:solidFill>
                   <a:srgbClr val="C9CFD8"/>
                 </a:solidFill>
-                <a:latin typeface="Segoe UI"/>
-              </a:rPr>
-              <a:t>подряд с отчуждением прав (переводчик недели 7)</a:t>
+                <a:latin typeface="Rubik"/>
+              </a:rPr>
+              <a:t>подряд с отчуждением прав (переводчик недели 7)</a:t>
             </a:r>
           </a:p>
         </p:txBody>

</xml_diff>

<commit_message>
docs: fix week 8 legal costs, shares, voting and IP details in report, agreement and slides
</commit_message>
<xml_diff>
--- a/READMEs/sem_7/week8/attachments/PiConstruct_Правовая_база.pptx
+++ b/READMEs/sem_7/week8/attachments/PiConstruct_Правовая_база.pptx
@@ -4230,7 +4230,7 @@
                 </a:solidFill>
                 <a:latin typeface="Rubik"/>
               </a:rPr>
-              <a:t>доли 20% × 5, УК 50 000 ₽, решения 3/5</a:t>
+              <a:t>доли по вкладу, УК 10 000 ₽, управляющий — ИП</a:t>
             </a:r>
           </a:p>
           <a:p>
@@ -4258,7 +4258,7 @@
                 </a:solidFill>
                 <a:latin typeface="Rubik"/>
               </a:rPr>
-              <a:t>регистрация электронно — 0 ₽ пошлин</a:t>
+              <a:t>через МФЦ — 0 ₽ пошлин; взносы ИП 57 390 ₽/год</a:t>
             </a:r>
           </a:p>
         </p:txBody>
@@ -4424,7 +4424,7 @@
                 </a:solidFill>
                 <a:latin typeface="Rubik"/>
               </a:rPr>
-              <a:t>знак «PiConstruct»: 8–⁠12 мес. и 42 000 ₽ пошлин в 3 классах МКТУ</a:t>
+              <a:t>знак «PiConstruct»: 8–⁠18 мес. и 42 000 ₽ пошлин в 3 классах МКТУ</a:t>
             </a:r>
           </a:p>
           <a:p>
@@ -4452,7 +4452,7 @@
                 </a:solidFill>
                 <a:latin typeface="Rubik"/>
               </a:rPr>
-              <a:t>piconstruct.ru свободен — регистрируем до заявки</a:t>
+              <a:t>piconstruct.ru свободен — регистрируем сразу</a:t>
             </a:r>
           </a:p>
           <a:p>
@@ -4646,7 +4646,7 @@
                 </a:solidFill>
                 <a:latin typeface="Rubik"/>
               </a:rPr>
-              <a:t>вестинг 4 года / клифф 12 мес. — равные доли справедливы</a:t>
+              <a:t>доли по вкладу + вестинг 4 года / клифф 12 мес.</a:t>
             </a:r>
           </a:p>
           <a:p>
@@ -4674,7 +4674,7 @@
                 </a:solidFill>
                 <a:latin typeface="Rubik"/>
               </a:rPr>
-              <a:t>выход через ROFR, неконкуренция 12 месяцев</a:t>
+              <a:t>выход через ROFR, неконкуренция — на время участия</a:t>
             </a:r>
           </a:p>
           <a:p>
@@ -5479,7 +5479,7 @@
                 </a:solidFill>
                 <a:latin typeface="Rubik"/>
               </a:rPr>
-              <a:t>20% × 5</a:t>
+              <a:t>по вкладу</a:t>
             </a:r>
           </a:p>
         </p:txBody>
@@ -5896,7 +5896,7 @@
                 </a:solidFill>
                 <a:latin typeface="Rubik"/>
               </a:rPr>
-              <a:t>≈ 0 ₽</a:t>
+              <a:t>57 390 ₽/год</a:t>
             </a:r>
           </a:p>
         </p:txBody>
@@ -6579,7 +6579,7 @@
                 </a:solidFill>
                 <a:latin typeface="Rubik"/>
               </a:rPr>
-              <a:t>отчётность минимальна, регистрация электронно — без пошлины</a:t>
+              <a:t>отчётность минимальна; главный расход — взносы 57 390 ₽/год</a:t>
             </a:r>
           </a:p>
           <a:p>
@@ -6733,7 +6733,7 @@
                 </a:solidFill>
                 <a:latin typeface="Rubik"/>
               </a:rPr>
-              <a:t>ООО: доли 20% × 5, УК 50 000 ₽</a:t>
+              <a:t>ООО: доли по вкладу, УК 10 000 ₽</a:t>
             </a:r>
           </a:p>
         </p:txBody>
@@ -6784,7 +6784,7 @@
                 </a:solidFill>
                 <a:latin typeface="Rubik"/>
               </a:rPr>
-              <a:t>генеральный директор — тимлид; решения большинством 3 из 5</a:t>
+              <a:t>управляющий — ИП тимлида; ключевые решения — 3/4 голосов</a:t>
             </a:r>
           </a:p>
           <a:p>
@@ -6840,7 +6840,7 @@
                 </a:solidFill>
                 <a:latin typeface="Rubik"/>
               </a:rPr>
-              <a:t>регистрация через сервис ФНС электронно — пошлина 0 ₽ (ст. 333.35 НК РФ)</a:t>
+              <a:t>регистрация через МФЦ — пошлина 0 ₽, юрадрес — жильё участника</a:t>
             </a:r>
           </a:p>
         </p:txBody>
@@ -6982,7 +6982,7 @@
                 </a:solidFill>
                 <a:latin typeface="Rubik"/>
               </a:rPr>
-              <a:t>При такой выручке бухгалтерия (≈ 5 000 ₽/мес) ≤ 17% дохода, а 90 000 ₽ за три месяца покрывают сопровождение и половину пошлин знака.</a:t>
+              <a:t>При такой выручке бухгалтерия (≈ 5 000 ₽/мес) — около 17% дохода; директор по трудовому договору (+≈ 15 000 ₽/мес) не нужен — управляет ИП.</a:t>
             </a:r>
           </a:p>
         </p:txBody>
@@ -7086,7 +7086,7 @@
                 </a:solidFill>
                 <a:latin typeface="Rubik"/>
               </a:rPr>
-              <a:t>Текущие — 3 из 5, ключевые — единогласно</a:t>
+              <a:t>Текущие — большинство, ключевые — 3/4</a:t>
             </a:r>
           </a:p>
         </p:txBody>
@@ -7251,7 +7251,7 @@
                 </a:solidFill>
                 <a:latin typeface="Rubik"/>
               </a:rPr>
-              <a:t>БОЛЬШИНСТВО · 3 ИЗ 5</a:t>
+              <a:t>БОЛЬШИНСТВО ГОЛОСОВ</a:t>
             </a:r>
           </a:p>
         </p:txBody>
@@ -7358,7 +7358,7 @@
                 </a:solidFill>
                 <a:latin typeface="Rubik"/>
               </a:rPr>
-              <a:t>пять голосов — нечётное число: тупик невозможен</a:t>
+              <a:t>голоса — пропорционально долям (ст. 32 ФЗ «Об ООО»)</a:t>
             </a:r>
           </a:p>
         </p:txBody>
@@ -7445,7 +7445,7 @@
                 </a:solidFill>
                 <a:latin typeface="Rubik"/>
               </a:rPr>
-              <a:t>ЕДИНОГЛАСНО · 5 ИЗ 5</a:t>
+              <a:t>НЕ МЕНЕЕ 3/4 ГОЛОСОВ</a:t>
             </a:r>
           </a:p>
         </p:txBody>
@@ -7524,7 +7524,7 @@
                 </a:solidFill>
                 <a:latin typeface="Rubik"/>
               </a:rPr>
-              <a:t>ликвидация, финансирование с размыванием долей</a:t>
+              <a:t>финансирование с размыванием; ликвидация — единогласно</a:t>
             </a:r>
           </a:p>
           <a:p>
@@ -7718,7 +7718,7 @@
                 </a:solidFill>
                 <a:latin typeface="Rubik"/>
               </a:rPr>
-              <a:t>ООО — в пределах вкладов; гендиректор — субсидиарная при виновном банкротстве</a:t>
+              <a:t>ООО — в пределах вкладов; управляющий — субсидиарная при виновном банкротстве</a:t>
             </a:r>
           </a:p>
         </p:txBody>
@@ -8686,7 +8686,7 @@
                 </a:solidFill>
                 <a:latin typeface="Rubik"/>
               </a:rPr>
-              <a:t>публиковать исходники сборки образа</a:t>
+              <a:t>исходники GPL-пакетов и наши изменения</a:t>
             </a:r>
           </a:p>
         </p:txBody>
@@ -8838,7 +8838,7 @@
                 </a:solidFill>
                 <a:latin typeface="Rubik"/>
               </a:rPr>
-              <a:t>piconstruct.ru свободен — регистрировать</a:t>
+              <a:t>piconstruct.ru — регистрировать сразу</a:t>
             </a:r>
           </a:p>
         </p:txBody>
@@ -8990,7 +8990,7 @@
                 </a:solidFill>
                 <a:latin typeface="Rubik"/>
               </a:rPr>
-              <a:t>уведомление РКН, реквизиты оператора</a:t>
+              <a:t>уведомление РКН — сразу после ИП</a:t>
             </a:r>
           </a:p>
         </p:txBody>
@@ -9497,7 +9497,7 @@
                 </a:solidFill>
                 <a:latin typeface="Rubik"/>
               </a:rPr>
-              <a:t>партнёрское соглашение — 0 ₽</a:t>
+              <a:t>ИП, уведомление РКН, домен .ru</a:t>
             </a:r>
           </a:p>
           <a:p>
@@ -9525,7 +9525,7 @@
                 </a:solidFill>
                 <a:latin typeface="Rubik"/>
               </a:rPr>
-              <a:t>5 договоров отчуждения прав</a:t>
+              <a:t>соглашение + 5 договоров отчуждения</a:t>
             </a:r>
           </a:p>
           <a:p>
@@ -9691,7 +9691,7 @@
                 </a:solidFill>
                 <a:latin typeface="Rubik"/>
               </a:rPr>
-              <a:t>уведомление Роскомнадзора — 0 ₽</a:t>
+              <a:t>пользовательское соглашение (оферта)</a:t>
             </a:r>
           </a:p>
           <a:p>
@@ -9719,7 +9719,7 @@
                 </a:solidFill>
                 <a:latin typeface="Rubik"/>
               </a:rPr>
-              <a:t>реквизиты оператора в политике</a:t>
+              <a:t>условия хранения меню клиентов</a:t>
             </a:r>
           </a:p>
           <a:p>
@@ -9747,7 +9747,7 @@
                 </a:solidFill>
                 <a:latin typeface="Rubik"/>
               </a:rPr>
-              <a:t>пользовательское соглашение на лендинг</a:t>
+              <a:t>публикация оферты на лендинге</a:t>
             </a:r>
           </a:p>
         </p:txBody>
@@ -9941,7 +9941,7 @@
                 </a:solidFill>
                 <a:latin typeface="Rubik"/>
               </a:rPr>
-              <a:t>пошлина 0 ₽ при подаче электронно</a:t>
+              <a:t>пошлина 0 ₽ через МФЦ</a:t>
             </a:r>
           </a:p>
         </p:txBody>
@@ -10135,7 +10135,7 @@
                 </a:solidFill>
                 <a:latin typeface="Rubik"/>
               </a:rPr>
-              <a:t>свидетельство — от 8 до 12 месяцев</a:t>
+              <a:t>свидетельство — от 8 до 18 месяцев</a:t>
             </a:r>
           </a:p>
         </p:txBody>
@@ -10637,7 +10637,7 @@
                 </a:solidFill>
                 <a:latin typeface="Rubik"/>
               </a:rPr>
-              <a:t>до ООО действует как простое товарищество (ст. 1041 ГК РФ), после — переносится в устав и корпоративный договор</a:t>
+              <a:t>до ООО — непоименованный договор (ст. 421 ГК РФ), после — переносится в устав и корпоративный договор</a:t>
             </a:r>
           </a:p>
           <a:p>
@@ -10813,7 +10813,7 @@
                 </a:solidFill>
                 <a:latin typeface="Rubik"/>
               </a:rPr>
-              <a:t>2. Вклады и доли — по 20%</a:t>
+              <a:t>2. Вклады и доли — по вкладу</a:t>
             </a:r>
           </a:p>
           <a:p>
@@ -10870,7 +10870,7 @@
                 </a:solidFill>
                 <a:latin typeface="Rubik"/>
               </a:rPr>
-              <a:t>5. Принятие решений — 3/5 и единогласно</a:t>
+              <a:t>5. Принятие решений — большинство и 3/4</a:t>
             </a:r>
           </a:p>
           <a:p>
@@ -11253,7 +11253,7 @@
                 </a:solidFill>
                 <a:latin typeface="Rubik"/>
               </a:rPr>
-              <a:t>20% × 5 + вестинг</a:t>
+              <a:t>Доли + вестинг</a:t>
             </a:r>
           </a:p>
         </p:txBody>
@@ -11292,7 +11292,7 @@
                 </a:solidFill>
                 <a:latin typeface="Rubik"/>
               </a:rPr>
-              <a:t>равные доли; закрепление — 4 года с клиффом 12 месяцев: уходит раньше — доля возвращается команде</a:t>
+              <a:t>доли по вкладу; закрепление — 4 года с клиффом 12 месяцев: уходит раньше — доля возвращается команде</a:t>
             </a:r>
           </a:p>
         </p:txBody>
@@ -11379,7 +11379,7 @@
                 </a:solidFill>
                 <a:latin typeface="Rubik"/>
               </a:rPr>
-              <a:t>Решения 3/5</a:t>
+              <a:t>Голосование</a:t>
             </a:r>
           </a:p>
         </p:txBody>
@@ -11418,7 +11418,7 @@
                 </a:solidFill>
                 <a:latin typeface="Rubik"/>
               </a:rPr>
-              <a:t>текущие — большинством, тупик исключён; ключевые (продажа долей, размывание, сделки &gt; 500 000 ₽) — единогласно</a:t>
+              <a:t>текущие — большинством голосов; ключевые (продажа долей, размывание, сделки &gt; 500 000 ₽) — не менее 3/4</a:t>
             </a:r>
           </a:p>
         </p:txBody>
@@ -11796,7 +11796,7 @@
                 </a:solidFill>
                 <a:latin typeface="Rubik"/>
               </a:rPr>
-              <a:t>запрет конкурирующих проектов в нише digital signage — во время участия и 12 месяцев после выхода</a:t>
+              <a:t>запрет конкурирующих проектов в нише digital signage — на время участия; после выхода — конфиденциальность 3 года</a:t>
             </a:r>
           </a:p>
         </p:txBody>
@@ -12417,7 +12417,7 @@
                 </a:solidFill>
                 <a:latin typeface="Rubik"/>
               </a:rPr>
-              <a:t>Равные доли без вестинга</a:t>
+              <a:t>Доли поровну и без вестинга</a:t>
             </a:r>
           </a:p>
         </p:txBody>
@@ -12456,7 +12456,7 @@
                 </a:solidFill>
                 <a:latin typeface="Rubik"/>
               </a:rPr>
-              <a:t>вестинг 4 года / клифф 12 месяцев (раздел 4 прототипа)</a:t>
+              <a:t>доли по вкладу + вестинг 4 года (разделы 2 и 4)</a:t>
             </a:r>
           </a:p>
         </p:txBody>
@@ -12682,7 +12682,7 @@
                 </a:solidFill>
                 <a:latin typeface="Rubik"/>
               </a:rPr>
-              <a:t>публикация скриптов сборки, страница «Открытый код»</a:t>
+              <a:t>исходники GPL-пакетов, страница «Открытый код»</a:t>
             </a:r>
           </a:p>
         </p:txBody>
@@ -12795,7 +12795,7 @@
                 </a:solidFill>
                 <a:latin typeface="Rubik"/>
               </a:rPr>
-              <a:t>уведомление при регистрации оператора; согласия уже собраны</a:t>
+              <a:t>уведомление РКН сразу после регистрации ИП</a:t>
             </a:r>
           </a:p>
         </p:txBody>

</xml_diff>